<commit_message>
docs: programmatically update PowerPoint slide text with actual GPU training metrics and live dashboard integration details
</commit_message>
<xml_diff>
--- a/BAO_CAO_TIEN_DO_KLTN.pptx
+++ b/BAO_CAO_TIEN_DO_KLTN.pptx
@@ -1955,12 +1955,7 @@
               </a:defRPr>
             </a:pPr>
             <a:r>
-              <a:rPr sz="1800">
-                <a:solidFill>
-                  <a:srgbClr val="17202A"/>
-                </a:solidFill>
-              </a:rPr>
-              <a:t>Đã hoàn thành phần baseline, workflow ABSA, tách train/eval và chạy được mô hình học sâu đầu tiên.</a:t>
+              <a:t>Đã hoàn thành tinh chỉnh PhoBERT đa tác vụ trên Kaggle GPU, đạt kết quả thực nghiệm tối ưu và tích hợp chạy live thành công vào Streamlit Dashboard &amp; Flask API.</a:t>
             </a:r>
           </a:p>
         </p:txBody>
@@ -3015,76 +3010,7 @@
               </a:defRPr>
             </a:pPr>
             <a:r>
-              <a:rPr sz="1800" dirty="0">
-                <a:solidFill>
-                  <a:srgbClr val="17202A"/>
-                </a:solidFill>
-              </a:rPr>
-              <a:t>• Model aspect </a:t>
-            </a:r>
-            <a:r>
-              <a:rPr sz="1800" dirty="0" err="1">
-                <a:solidFill>
-                  <a:srgbClr val="17202A"/>
-                </a:solidFill>
-              </a:rPr>
-              <a:t>đã</a:t>
-            </a:r>
-            <a:r>
-              <a:rPr sz="1800" dirty="0">
-                <a:solidFill>
-                  <a:srgbClr val="17202A"/>
-                </a:solidFill>
-              </a:rPr>
-              <a:t> </a:t>
-            </a:r>
-            <a:r>
-              <a:rPr sz="1800" dirty="0" err="1">
-                <a:solidFill>
-                  <a:srgbClr val="17202A"/>
-                </a:solidFill>
-              </a:rPr>
-              <a:t>tích</a:t>
-            </a:r>
-            <a:r>
-              <a:rPr sz="1800" dirty="0">
-                <a:solidFill>
-                  <a:srgbClr val="17202A"/>
-                </a:solidFill>
-              </a:rPr>
-              <a:t> </a:t>
-            </a:r>
-            <a:r>
-              <a:rPr sz="1800" dirty="0" err="1">
-                <a:solidFill>
-                  <a:srgbClr val="17202A"/>
-                </a:solidFill>
-              </a:rPr>
-              <a:t>hợp</a:t>
-            </a:r>
-            <a:r>
-              <a:rPr sz="1800" dirty="0">
-                <a:solidFill>
-                  <a:srgbClr val="17202A"/>
-                </a:solidFill>
-              </a:rPr>
-              <a:t> </a:t>
-            </a:r>
-            <a:r>
-              <a:rPr sz="1800" dirty="0" err="1">
-                <a:solidFill>
-                  <a:srgbClr val="17202A"/>
-                </a:solidFill>
-              </a:rPr>
-              <a:t>vào</a:t>
-            </a:r>
-            <a:r>
-              <a:rPr sz="1800" dirty="0">
-                <a:solidFill>
-                  <a:srgbClr val="17202A"/>
-                </a:solidFill>
-              </a:rPr>
-              <a:t> API/dashboard</a:t>
+              <a:t>• Tích hợp live thành công mô hình PhoBERT PyTorch vào Web Dashboard &amp; Flask API</a:t>
             </a:r>
           </a:p>
         </p:txBody>
@@ -3250,12 +3176,7 @@
               </a:defRPr>
             </a:pPr>
             <a:r>
-              <a:rPr sz="1800">
-                <a:solidFill>
-                  <a:srgbClr val="17202A"/>
-                </a:solidFill>
-              </a:rPr>
-              <a:t>• Đã cài xong môi trường deep learning, chạy được Bi-LSTM và PhoBERT trong local</a:t>
+              <a:t>• Đã tinh chỉnh thành công PhoBERT trên GPU T4, đạt Aspect F1 0.5669 và Sentiment F1 0.5819</a:t>
             </a:r>
           </a:p>
         </p:txBody>
@@ -6425,12 +6346,7 @@
               </a:defRPr>
             </a:pPr>
             <a:r>
-              <a:rPr sz="2700" b="1">
-                <a:solidFill>
-                  <a:srgbClr val="17202A"/>
-                </a:solidFill>
-              </a:rPr>
-              <a:t>Micro F1 0.4325</a:t>
+              <a:t>Aspect F1-m: 0.5669 | Sentiment F1-M: 0.5819</a:t>
             </a:r>
           </a:p>
         </p:txBody>
@@ -6470,12 +6386,7 @@
               </a:defRPr>
             </a:pPr>
             <a:r>
-              <a:rPr sz="1050">
-                <a:solidFill>
-                  <a:srgbClr val="4B5563"/>
-                </a:solidFill>
-              </a:rPr>
-              <a:t>Chỉ là lượt chạy thử 1 epoch CPU</a:t>
+              <a:t>Huấn luyện 5 epochs đa tác vụ trên GPU T4</a:t>
             </a:r>
           </a:p>
         </p:txBody>
@@ -6551,12 +6462,7 @@
               </a:defRPr>
             </a:pPr>
             <a:r>
-              <a:rPr sz="2100" b="1">
-                <a:solidFill>
-                  <a:srgbClr val="17202A"/>
-                </a:solidFill>
-              </a:rPr>
-              <a:t>Kết luận tạm thời</a:t>
+              <a:t>Kết luận &amp; Cột mốc Deep Learning</a:t>
             </a:r>
           </a:p>
         </p:txBody>
@@ -6766,124 +6672,7 @@
               </a:defRPr>
             </a:pPr>
             <a:r>
-              <a:rPr sz="1800" dirty="0">
-                <a:solidFill>
-                  <a:srgbClr val="17202A"/>
-                </a:solidFill>
-              </a:rPr>
-              <a:t>• </a:t>
-            </a:r>
-            <a:r>
-              <a:rPr sz="1800" dirty="0" err="1">
-                <a:solidFill>
-                  <a:srgbClr val="17202A"/>
-                </a:solidFill>
-              </a:rPr>
-              <a:t>PhoBERT</a:t>
-            </a:r>
-            <a:r>
-              <a:rPr sz="1800" dirty="0">
-                <a:solidFill>
-                  <a:srgbClr val="17202A"/>
-                </a:solidFill>
-              </a:rPr>
-              <a:t> </a:t>
-            </a:r>
-            <a:r>
-              <a:rPr sz="1800" dirty="0" err="1">
-                <a:solidFill>
-                  <a:srgbClr val="17202A"/>
-                </a:solidFill>
-              </a:rPr>
-              <a:t>đã</a:t>
-            </a:r>
-            <a:r>
-              <a:rPr sz="1800" dirty="0">
-                <a:solidFill>
-                  <a:srgbClr val="17202A"/>
-                </a:solidFill>
-              </a:rPr>
-              <a:t> </a:t>
-            </a:r>
-            <a:r>
-              <a:rPr sz="1800" dirty="0" err="1">
-                <a:solidFill>
-                  <a:srgbClr val="17202A"/>
-                </a:solidFill>
-              </a:rPr>
-              <a:t>chạy</a:t>
-            </a:r>
-            <a:r>
-              <a:rPr sz="1800" dirty="0">
-                <a:solidFill>
-                  <a:srgbClr val="17202A"/>
-                </a:solidFill>
-              </a:rPr>
-              <a:t> </a:t>
-            </a:r>
-            <a:r>
-              <a:rPr sz="1800" dirty="0" err="1">
-                <a:solidFill>
-                  <a:srgbClr val="17202A"/>
-                </a:solidFill>
-              </a:rPr>
-              <a:t>được</a:t>
-            </a:r>
-            <a:r>
-              <a:rPr sz="1800" dirty="0">
-                <a:solidFill>
-                  <a:srgbClr val="17202A"/>
-                </a:solidFill>
-              </a:rPr>
-              <a:t> end-to-end </a:t>
-            </a:r>
-            <a:r>
-              <a:rPr sz="1800" dirty="0" err="1">
-                <a:solidFill>
-                  <a:srgbClr val="17202A"/>
-                </a:solidFill>
-              </a:rPr>
-              <a:t>trong</a:t>
-            </a:r>
-            <a:r>
-              <a:rPr sz="1800" dirty="0">
-                <a:solidFill>
-                  <a:srgbClr val="17202A"/>
-                </a:solidFill>
-              </a:rPr>
-              <a:t> </a:t>
-            </a:r>
-            <a:r>
-              <a:rPr sz="1800" dirty="0" err="1">
-                <a:solidFill>
-                  <a:srgbClr val="17202A"/>
-                </a:solidFill>
-              </a:rPr>
-              <a:t>môi</a:t>
-            </a:r>
-            <a:r>
-              <a:rPr sz="1800" dirty="0">
-                <a:solidFill>
-                  <a:srgbClr val="17202A"/>
-                </a:solidFill>
-              </a:rPr>
-              <a:t> </a:t>
-            </a:r>
-            <a:r>
-              <a:rPr sz="1800" dirty="0" err="1">
-                <a:solidFill>
-                  <a:srgbClr val="17202A"/>
-                </a:solidFill>
-              </a:rPr>
-              <a:t>trường</a:t>
-            </a:r>
-            <a:r>
-              <a:rPr sz="1800" dirty="0">
-                <a:solidFill>
-                  <a:srgbClr val="17202A"/>
-                </a:solidFill>
-              </a:rPr>
-              <a:t> local</a:t>
+              <a:t>• PhoBERT GPU đạt hiệu năng cao và đã được tích hợp chạy live thành công</a:t>
             </a:r>
           </a:p>
         </p:txBody>
@@ -6923,132 +6712,7 @@
               </a:defRPr>
             </a:pPr>
             <a:r>
-              <a:rPr sz="1800" dirty="0">
-                <a:solidFill>
-                  <a:srgbClr val="17202A"/>
-                </a:solidFill>
-              </a:rPr>
-              <a:t>• </a:t>
-            </a:r>
-            <a:r>
-              <a:rPr sz="1800" dirty="0" err="1">
-                <a:solidFill>
-                  <a:srgbClr val="17202A"/>
-                </a:solidFill>
-              </a:rPr>
-              <a:t>Chưa</a:t>
-            </a:r>
-            <a:r>
-              <a:rPr sz="1800" dirty="0">
-                <a:solidFill>
-                  <a:srgbClr val="17202A"/>
-                </a:solidFill>
-              </a:rPr>
-              <a:t> </a:t>
-            </a:r>
-            <a:r>
-              <a:rPr sz="1800" dirty="0" err="1">
-                <a:solidFill>
-                  <a:srgbClr val="17202A"/>
-                </a:solidFill>
-              </a:rPr>
-              <a:t>có</a:t>
-            </a:r>
-            <a:r>
-              <a:rPr sz="1800" dirty="0">
-                <a:solidFill>
-                  <a:srgbClr val="17202A"/>
-                </a:solidFill>
-              </a:rPr>
-              <a:t> </a:t>
-            </a:r>
-            <a:r>
-              <a:rPr sz="1800" dirty="0" err="1">
-                <a:solidFill>
-                  <a:srgbClr val="17202A"/>
-                </a:solidFill>
-              </a:rPr>
-              <a:t>mô</a:t>
-            </a:r>
-            <a:r>
-              <a:rPr sz="1800" dirty="0">
-                <a:solidFill>
-                  <a:srgbClr val="17202A"/>
-                </a:solidFill>
-              </a:rPr>
-              <a:t> </a:t>
-            </a:r>
-            <a:r>
-              <a:rPr sz="1800" dirty="0" err="1">
-                <a:solidFill>
-                  <a:srgbClr val="17202A"/>
-                </a:solidFill>
-              </a:rPr>
-              <a:t>hình</a:t>
-            </a:r>
-            <a:r>
-              <a:rPr sz="1800" dirty="0">
-                <a:solidFill>
-                  <a:srgbClr val="17202A"/>
-                </a:solidFill>
-              </a:rPr>
-              <a:t> </a:t>
-            </a:r>
-            <a:r>
-              <a:rPr sz="1800" dirty="0" err="1">
-                <a:solidFill>
-                  <a:srgbClr val="17202A"/>
-                </a:solidFill>
-              </a:rPr>
-              <a:t>nào</a:t>
-            </a:r>
-            <a:r>
-              <a:rPr sz="1800" dirty="0">
-                <a:solidFill>
-                  <a:srgbClr val="17202A"/>
-                </a:solidFill>
-              </a:rPr>
-              <a:t> </a:t>
-            </a:r>
-            <a:r>
-              <a:rPr sz="1800" dirty="0" err="1">
-                <a:solidFill>
-                  <a:srgbClr val="17202A"/>
-                </a:solidFill>
-              </a:rPr>
-              <a:t>vượt</a:t>
-            </a:r>
-            <a:r>
-              <a:rPr sz="1800" dirty="0">
-                <a:solidFill>
-                  <a:srgbClr val="17202A"/>
-                </a:solidFill>
-              </a:rPr>
-              <a:t> baseline ABSA </a:t>
-            </a:r>
-            <a:r>
-              <a:rPr sz="1800" dirty="0" err="1">
-                <a:solidFill>
-                  <a:srgbClr val="17202A"/>
-                </a:solidFill>
-              </a:rPr>
-              <a:t>hiện</a:t>
-            </a:r>
-            <a:r>
-              <a:rPr sz="1800" dirty="0">
-                <a:solidFill>
-                  <a:srgbClr val="17202A"/>
-                </a:solidFill>
-              </a:rPr>
-              <a:t> </a:t>
-            </a:r>
-            <a:r>
-              <a:rPr sz="1800" dirty="0" err="1">
-                <a:solidFill>
-                  <a:srgbClr val="17202A"/>
-                </a:solidFill>
-              </a:rPr>
-              <a:t>tại</a:t>
+              <a:t>• PhoBERT đạt độ chính xác tối ưu về phân loại Cảm xúc (Accuracy 0.6200)</a:t>
             </a:r>
             <a:endParaRPr sz="1800" dirty="0">
               <a:solidFill>
@@ -7174,12 +6838,7 @@
               </a:defRPr>
             </a:pPr>
             <a:r>
-              <a:rPr sz="1800">
-                <a:solidFill>
-                  <a:srgbClr val="17202A"/>
-                </a:solidFill>
-              </a:rPr>
-              <a:t>• PhoBERT mới chỉ 1 epoch và chạy trên CPU</a:t>
+              <a:t>• Đã chạy 5 epochs trên Kaggle GPU T4 (Mixed Precision) cực nhanh</a:t>
             </a:r>
           </a:p>
         </p:txBody>
@@ -7219,12 +6878,7 @@
               </a:defRPr>
             </a:pPr>
             <a:r>
-              <a:rPr sz="1800">
-                <a:solidFill>
-                  <a:srgbClr val="17202A"/>
-                </a:solidFill>
-              </a:rPr>
-              <a:t>• Kết quả hiện tại chưa thể xem là fine-tune đầy đủ</a:t>
+              <a:t>• Dự đoán đồng thời khía cạnh &amp; cảm xúc (Multitask)</a:t>
             </a:r>
           </a:p>
         </p:txBody>
@@ -7264,12 +6918,7 @@
               </a:defRPr>
             </a:pPr>
             <a:r>
-              <a:rPr sz="1800">
-                <a:solidFill>
-                  <a:srgbClr val="17202A"/>
-                </a:solidFill>
-              </a:rPr>
-              <a:t>• Cần thêm epoch và tốt nhất là GPU để đánh giá công bằng</a:t>
+              <a:t>• Chạy Batch Inference thành công trên 100k review thô chỉ trong 2 phút</a:t>
             </a:r>
           </a:p>
         </p:txBody>
@@ -7513,12 +7162,7 @@
               </a:defRPr>
             </a:pPr>
             <a:r>
-              <a:rPr sz="1800">
-                <a:solidFill>
-                  <a:srgbClr val="17202A"/>
-                </a:solidFill>
-              </a:rPr>
-              <a:t>• Tinh chỉnh PhoBERT nghiêm túc hơn nếu có GPU</a:t>
+              <a:t>• Mở rộng tập gán nhãn huấn luyện lên 2,000 dòng để nâng cao độ chính xác của PhoBERT.</a:t>
             </a:r>
           </a:p>
         </p:txBody>
@@ -7558,12 +7202,7 @@
               </a:defRPr>
             </a:pPr>
             <a:r>
-              <a:rPr sz="1800">
-                <a:solidFill>
-                  <a:srgbClr val="17202A"/>
-                </a:solidFill>
-              </a:rPr>
-              <a:t>• Lập bảng so sánh cuối giữa baseline, Bi-LSTM, PhoBERT</a:t>
+              <a:t>• Ánh xạ kết quả gán nhãn quy mô lớn (100k dòng) vào khung chiến lược RACE và eWOM.</a:t>
             </a:r>
           </a:p>
         </p:txBody>
@@ -7603,12 +7242,7 @@
               </a:defRPr>
             </a:pPr>
             <a:r>
-              <a:rPr sz="1800">
-                <a:solidFill>
-                  <a:srgbClr val="17202A"/>
-                </a:solidFill>
-              </a:rPr>
-              <a:t>• Chốt nhận xét theo từng aspect, đặc biệt product, service, app</a:t>
+              <a:t>• Hoàn thiện viết Quyển khóa luận tốt nghiệp (Chương 4 &amp; Chương 5).</a:t>
             </a:r>
           </a:p>
         </p:txBody>

</xml_diff>

<commit_message>
feat: update dashboard translations to match new 70% train and 30% predict dataset split
</commit_message>
<xml_diff>
--- a/BAO_CAO_TIEN_DO_KLTN.pptx
+++ b/BAO_CAO_TIEN_DO_KLTN.pptx
@@ -887,6 +887,552 @@
 </c:chartSpace>
 </file>
 
+<file path=ppt/charts/chart3.xml><?xml version="1.0" encoding="utf-8"?>
+<c:chartSpace xmlns:c="http://schemas.openxmlformats.org/drawingml/2006/chart" xmlns:a="http://schemas.openxmlformats.org/drawingml/2006/main" xmlns:r="http://schemas.openxmlformats.org/officeDocument/2006/relationships">
+  <c:date1904 val="0"/>
+  <c:chart>
+    <c:autoTitleDeleted val="0"/>
+    <c:plotArea>
+      <c:barChart>
+        <c:barDir val="col"/>
+        <c:grouping val="clustered"/>
+        <c:ser>
+          <c:idx val="0"/>
+          <c:order val="0"/>
+          <c:tx>
+            <c:strRef>
+              <c:f>Sheet1!$B$1</c:f>
+              <c:strCache>
+                <c:ptCount val="1"/>
+                <c:pt idx="0">
+                  <c:v>Aspect F1-micro</c:v>
+                </c:pt>
+              </c:strCache>
+            </c:strRef>
+          </c:tx>
+          <c:cat>
+            <c:strRef>
+              <c:f>Sheet1!$A$2:$A$4</c:f>
+              <c:strCache>
+                <c:ptCount val="3"/>
+                <c:pt idx="0">
+                  <c:v>Baseline SVM</c:v>
+                </c:pt>
+                <c:pt idx="1">
+                  <c:v>Bi-LSTM</c:v>
+                </c:pt>
+                <c:pt idx="2">
+                  <c:v>PhoBERT Multi-task</c:v>
+                </c:pt>
+              </c:strCache>
+            </c:strRef>
+          </c:cat>
+          <c:val>
+            <c:numRef>
+              <c:f>Sheet1!$B$2:$B$4</c:f>
+              <c:numCache>
+                <c:formatCode>General</c:formatCode>
+                <c:ptCount val="3"/>
+                <c:pt idx="0">
+                  <c:v>0.8525</c:v>
+                </c:pt>
+                <c:pt idx="1">
+                  <c:v>0.7487</c:v>
+                </c:pt>
+                <c:pt idx="2">
+                  <c:v>0.9737</c:v>
+                </c:pt>
+              </c:numCache>
+            </c:numRef>
+          </c:val>
+        </c:ser>
+        <c:ser>
+          <c:idx val="1"/>
+          <c:order val="1"/>
+          <c:tx>
+            <c:strRef>
+              <c:f>Sheet1!$C$1</c:f>
+              <c:strCache>
+                <c:ptCount val="1"/>
+                <c:pt idx="0">
+                  <c:v>Aspect F1-macro</c:v>
+                </c:pt>
+              </c:strCache>
+            </c:strRef>
+          </c:tx>
+          <c:cat>
+            <c:strRef>
+              <c:f>Sheet1!$A$2:$A$4</c:f>
+              <c:strCache>
+                <c:ptCount val="3"/>
+                <c:pt idx="0">
+                  <c:v>Baseline SVM</c:v>
+                </c:pt>
+                <c:pt idx="1">
+                  <c:v>Bi-LSTM</c:v>
+                </c:pt>
+                <c:pt idx="2">
+                  <c:v>PhoBERT Multi-task</c:v>
+                </c:pt>
+              </c:strCache>
+            </c:strRef>
+          </c:cat>
+          <c:val>
+            <c:numRef>
+              <c:f>Sheet1!$C$2:$C$4</c:f>
+              <c:numCache>
+                <c:formatCode>General</c:formatCode>
+                <c:ptCount val="3"/>
+                <c:pt idx="0">
+                  <c:v>0.7837</c:v>
+                </c:pt>
+                <c:pt idx="1">
+                  <c:v>0.6816</c:v>
+                </c:pt>
+                <c:pt idx="2">
+                  <c:v>0.9751</c:v>
+                </c:pt>
+              </c:numCache>
+            </c:numRef>
+          </c:val>
+        </c:ser>
+        <c:dLbls>
+          <c:numFmt formatCode="0.00%" sourceLinked="0"/>
+          <c:txPr>
+            <a:bodyPr/>
+            <a:lstStyle/>
+            <a:p>
+              <a:pPr>
+                <a:defRPr sz="1000">
+                  <a:solidFill>
+                    <a:srgbClr val="0F172A"/>
+                  </a:solidFill>
+                  <a:latin typeface="Arial"/>
+                </a:defRPr>
+              </a:pPr>
+            </a:p>
+          </c:txPr>
+          <c:showLegendKey val="0"/>
+          <c:showVal val="1"/>
+          <c:showCatName val="0"/>
+          <c:showSerName val="0"/>
+          <c:showPercent val="0"/>
+          <c:showBubbleSize val="0"/>
+          <c:showLeaderLines val="1"/>
+        </c:dLbls>
+        <c:axId val="-2068027336"/>
+        <c:axId val="-2113994440"/>
+      </c:barChart>
+      <c:catAx>
+        <c:axId val="-2068027336"/>
+        <c:scaling>
+          <c:orientation val="minMax"/>
+        </c:scaling>
+        <c:delete val="0"/>
+        <c:axPos val="b"/>
+        <c:majorTickMark val="out"/>
+        <c:minorTickMark val="none"/>
+        <c:tickLblPos val="nextTo"/>
+        <c:txPr>
+          <a:bodyPr/>
+          <a:lstStyle/>
+          <a:p>
+            <a:pPr>
+              <a:defRPr sz="1100">
+                <a:solidFill>
+                  <a:srgbClr val="475569"/>
+                </a:solidFill>
+                <a:latin typeface="Arial"/>
+              </a:defRPr>
+            </a:pPr>
+          </a:p>
+        </c:txPr>
+        <c:crossAx val="-2113994440"/>
+        <c:crosses val="autoZero"/>
+        <c:auto val="1"/>
+        <c:lblAlgn val="ctr"/>
+        <c:lblOffset val="100"/>
+        <c:noMultiLvlLbl val="0"/>
+      </c:catAx>
+      <c:valAx>
+        <c:axId val="-2113994440"/>
+        <c:scaling/>
+        <c:delete val="0"/>
+        <c:axPos val="l"/>
+        <c:majorGridlines/>
+        <c:majorTickMark val="out"/>
+        <c:minorTickMark val="none"/>
+        <c:tickLblPos val="nextTo"/>
+        <c:txPr>
+          <a:bodyPr/>
+          <a:lstStyle/>
+          <a:p>
+            <a:pPr>
+              <a:defRPr sz="1100">
+                <a:solidFill>
+                  <a:srgbClr val="475569"/>
+                </a:solidFill>
+                <a:latin typeface="Arial"/>
+              </a:defRPr>
+            </a:pPr>
+          </a:p>
+        </c:txPr>
+        <c:crossAx val="-2068027336"/>
+        <c:crosses val="autoZero"/>
+      </c:valAx>
+    </c:plotArea>
+    <c:legend>
+      <c:legendPos val="t"/>
+      <c:overlay val="1"/>
+      <c:txPr>
+        <a:bodyPr/>
+        <a:lstStyle/>
+        <a:p>
+          <a:pPr>
+            <a:defRPr sz="1100">
+              <a:solidFill>
+                <a:srgbClr val="475569"/>
+              </a:solidFill>
+              <a:latin typeface="Arial"/>
+            </a:defRPr>
+          </a:pPr>
+        </a:p>
+      </c:txPr>
+    </c:legend>
+    <c:dispBlanksAs val="gap"/>
+  </c:chart>
+  <c:txPr>
+    <a:bodyPr/>
+    <a:lstStyle/>
+    <a:p>
+      <a:pPr>
+        <a:defRPr sz="1800"/>
+      </a:pPr>
+      <a:endParaRPr lang="en-US"/>
+    </a:p>
+  </c:txPr>
+  <c:externalData r:id="rId1">
+    <c:autoUpdate val="0"/>
+  </c:externalData>
+</c:chartSpace>
+</file>
+
+<file path=ppt/charts/chart4.xml><?xml version="1.0" encoding="utf-8"?>
+<c:chartSpace xmlns:c="http://schemas.openxmlformats.org/drawingml/2006/chart" xmlns:a="http://schemas.openxmlformats.org/drawingml/2006/main" xmlns:r="http://schemas.openxmlformats.org/officeDocument/2006/relationships">
+  <c:date1904 val="0"/>
+  <c:chart>
+    <c:autoTitleDeleted val="0"/>
+    <c:plotArea>
+      <c:barChart>
+        <c:barDir val="col"/>
+        <c:grouping val="clustered"/>
+        <c:ser>
+          <c:idx val="0"/>
+          <c:order val="0"/>
+          <c:tx>
+            <c:strRef>
+              <c:f>Sheet1!$B$1</c:f>
+              <c:strCache>
+                <c:ptCount val="1"/>
+                <c:pt idx="0">
+                  <c:v>Baseline SVM</c:v>
+                </c:pt>
+              </c:strCache>
+            </c:strRef>
+          </c:tx>
+          <c:cat>
+            <c:strRef>
+              <c:f>Sheet1!$A$2:$A$6</c:f>
+              <c:strCache>
+                <c:ptCount val="5"/>
+                <c:pt idx="0">
+                  <c:v>Giao hàng</c:v>
+                </c:pt>
+                <c:pt idx="1">
+                  <c:v>Giá cả</c:v>
+                </c:pt>
+                <c:pt idx="2">
+                  <c:v>Ứng dụng</c:v>
+                </c:pt>
+                <c:pt idx="3">
+                  <c:v>Sản phẩm</c:v>
+                </c:pt>
+                <c:pt idx="4">
+                  <c:v>Dịch vụ</c:v>
+                </c:pt>
+              </c:strCache>
+            </c:strRef>
+          </c:cat>
+          <c:val>
+            <c:numRef>
+              <c:f>Sheet1!$B$2:$B$6</c:f>
+              <c:numCache>
+                <c:formatCode>General</c:formatCode>
+                <c:ptCount val="5"/>
+                <c:pt idx="0">
+                  <c:v>0.8936</c:v>
+                </c:pt>
+                <c:pt idx="1">
+                  <c:v>0.7018</c:v>
+                </c:pt>
+                <c:pt idx="2">
+                  <c:v>0.8689</c:v>
+                </c:pt>
+                <c:pt idx="3">
+                  <c:v>0.9011</c:v>
+                </c:pt>
+                <c:pt idx="4">
+                  <c:v>0.5532</c:v>
+                </c:pt>
+              </c:numCache>
+            </c:numRef>
+          </c:val>
+        </c:ser>
+        <c:ser>
+          <c:idx val="1"/>
+          <c:order val="1"/>
+          <c:tx>
+            <c:strRef>
+              <c:f>Sheet1!$C$1</c:f>
+              <c:strCache>
+                <c:ptCount val="1"/>
+                <c:pt idx="0">
+                  <c:v>Bi-LSTM</c:v>
+                </c:pt>
+              </c:strCache>
+            </c:strRef>
+          </c:tx>
+          <c:cat>
+            <c:strRef>
+              <c:f>Sheet1!$A$2:$A$6</c:f>
+              <c:strCache>
+                <c:ptCount val="5"/>
+                <c:pt idx="0">
+                  <c:v>Giao hàng</c:v>
+                </c:pt>
+                <c:pt idx="1">
+                  <c:v>Giá cả</c:v>
+                </c:pt>
+                <c:pt idx="2">
+                  <c:v>Ứng dụng</c:v>
+                </c:pt>
+                <c:pt idx="3">
+                  <c:v>Sản phẩm</c:v>
+                </c:pt>
+                <c:pt idx="4">
+                  <c:v>Dịch vụ</c:v>
+                </c:pt>
+              </c:strCache>
+            </c:strRef>
+          </c:cat>
+          <c:val>
+            <c:numRef>
+              <c:f>Sheet1!$C$2:$C$6</c:f>
+              <c:numCache>
+                <c:formatCode>General</c:formatCode>
+                <c:ptCount val="5"/>
+                <c:pt idx="0">
+                  <c:v>0.7657</c:v>
+                </c:pt>
+                <c:pt idx="1">
+                  <c:v>0.5324</c:v>
+                </c:pt>
+                <c:pt idx="2">
+                  <c:v>0.8021</c:v>
+                </c:pt>
+                <c:pt idx="3">
+                  <c:v>0.8529</c:v>
+                </c:pt>
+                <c:pt idx="4">
+                  <c:v>0.4552</c:v>
+                </c:pt>
+              </c:numCache>
+            </c:numRef>
+          </c:val>
+        </c:ser>
+        <c:ser>
+          <c:idx val="2"/>
+          <c:order val="2"/>
+          <c:tx>
+            <c:strRef>
+              <c:f>Sheet1!$D$1</c:f>
+              <c:strCache>
+                <c:ptCount val="1"/>
+                <c:pt idx="0">
+                  <c:v>PhoBERT Multi-task</c:v>
+                </c:pt>
+              </c:strCache>
+            </c:strRef>
+          </c:tx>
+          <c:cat>
+            <c:strRef>
+              <c:f>Sheet1!$A$2:$A$6</c:f>
+              <c:strCache>
+                <c:ptCount val="5"/>
+                <c:pt idx="0">
+                  <c:v>Giao hàng</c:v>
+                </c:pt>
+                <c:pt idx="1">
+                  <c:v>Giá cả</c:v>
+                </c:pt>
+                <c:pt idx="2">
+                  <c:v>Ứng dụng</c:v>
+                </c:pt>
+                <c:pt idx="3">
+                  <c:v>Sản phẩm</c:v>
+                </c:pt>
+                <c:pt idx="4">
+                  <c:v>Dịch vụ</c:v>
+                </c:pt>
+              </c:strCache>
+            </c:strRef>
+          </c:cat>
+          <c:val>
+            <c:numRef>
+              <c:f>Sheet1!$D$2:$D$6</c:f>
+              <c:numCache>
+                <c:formatCode>General</c:formatCode>
+                <c:ptCount val="5"/>
+                <c:pt idx="0">
+                  <c:v>0.9862</c:v>
+                </c:pt>
+                <c:pt idx="1">
+                  <c:v>0.995</c:v>
+                </c:pt>
+                <c:pt idx="2">
+                  <c:v>0.9837</c:v>
+                </c:pt>
+                <c:pt idx="3">
+                  <c:v>0.9622</c:v>
+                </c:pt>
+                <c:pt idx="4">
+                  <c:v>0.9481</c:v>
+                </c:pt>
+              </c:numCache>
+            </c:numRef>
+          </c:val>
+        </c:ser>
+        <c:dLbls>
+          <c:numFmt formatCode="0.00%" sourceLinked="0"/>
+          <c:txPr>
+            <a:bodyPr/>
+            <a:lstStyle/>
+            <a:p>
+              <a:pPr>
+                <a:defRPr sz="1000">
+                  <a:solidFill>
+                    <a:srgbClr val="0F172A"/>
+                  </a:solidFill>
+                  <a:latin typeface="Arial"/>
+                </a:defRPr>
+              </a:pPr>
+            </a:p>
+          </c:txPr>
+          <c:showLegendKey val="0"/>
+          <c:showVal val="1"/>
+          <c:showCatName val="0"/>
+          <c:showSerName val="0"/>
+          <c:showPercent val="0"/>
+          <c:showBubbleSize val="0"/>
+          <c:showLeaderLines val="1"/>
+        </c:dLbls>
+        <c:axId val="-2068027336"/>
+        <c:axId val="-2113994440"/>
+      </c:barChart>
+      <c:catAx>
+        <c:axId val="-2068027336"/>
+        <c:scaling>
+          <c:orientation val="minMax"/>
+        </c:scaling>
+        <c:delete val="0"/>
+        <c:axPos val="b"/>
+        <c:majorTickMark val="out"/>
+        <c:minorTickMark val="none"/>
+        <c:tickLblPos val="nextTo"/>
+        <c:txPr>
+          <a:bodyPr/>
+          <a:lstStyle/>
+          <a:p>
+            <a:pPr>
+              <a:defRPr sz="1100">
+                <a:solidFill>
+                  <a:srgbClr val="475569"/>
+                </a:solidFill>
+                <a:latin typeface="Arial"/>
+              </a:defRPr>
+            </a:pPr>
+          </a:p>
+        </c:txPr>
+        <c:crossAx val="-2113994440"/>
+        <c:crosses val="autoZero"/>
+        <c:auto val="1"/>
+        <c:lblAlgn val="ctr"/>
+        <c:lblOffset val="100"/>
+        <c:noMultiLvlLbl val="0"/>
+      </c:catAx>
+      <c:valAx>
+        <c:axId val="-2113994440"/>
+        <c:scaling/>
+        <c:delete val="0"/>
+        <c:axPos val="l"/>
+        <c:majorGridlines/>
+        <c:majorTickMark val="out"/>
+        <c:minorTickMark val="none"/>
+        <c:tickLblPos val="nextTo"/>
+        <c:txPr>
+          <a:bodyPr/>
+          <a:lstStyle/>
+          <a:p>
+            <a:pPr>
+              <a:defRPr sz="1100">
+                <a:solidFill>
+                  <a:srgbClr val="475569"/>
+                </a:solidFill>
+                <a:latin typeface="Arial"/>
+              </a:defRPr>
+            </a:pPr>
+          </a:p>
+        </c:txPr>
+        <c:crossAx val="-2068027336"/>
+        <c:crosses val="autoZero"/>
+      </c:valAx>
+    </c:plotArea>
+    <c:legend>
+      <c:legendPos val="t"/>
+      <c:overlay val="1"/>
+      <c:txPr>
+        <a:bodyPr/>
+        <a:lstStyle/>
+        <a:p>
+          <a:pPr>
+            <a:defRPr sz="1100">
+              <a:solidFill>
+                <a:srgbClr val="475569"/>
+              </a:solidFill>
+              <a:latin typeface="Arial"/>
+            </a:defRPr>
+          </a:pPr>
+        </a:p>
+      </c:txPr>
+    </c:legend>
+    <c:dispBlanksAs val="gap"/>
+  </c:chart>
+  <c:txPr>
+    <a:bodyPr/>
+    <a:lstStyle/>
+    <a:p>
+      <a:pPr>
+        <a:defRPr sz="1800"/>
+      </a:pPr>
+      <a:endParaRPr lang="en-US"/>
+    </a:p>
+  </c:txPr>
+  <c:externalData r:id="rId1">
+    <c:autoUpdate val="0"/>
+  </c:externalData>
+</c:chartSpace>
+</file>
+
 <file path=ppt/notesMasters/notesMaster1.xml><?xml version="1.0" encoding="utf-8"?>
 <p:notesMaster xmlns:a="http://schemas.openxmlformats.org/drawingml/2006/main" xmlns:r="http://schemas.openxmlformats.org/officeDocument/2006/relationships" xmlns:p="http://schemas.openxmlformats.org/presentationml/2006/main">
   <p:cSld>
@@ -2774,7 +3320,7 @@
           <a:noFill/>
         </p:spPr>
         <p:txBody>
-          <a:bodyPr wrap="square" lIns="0" tIns="0" rIns="0" bIns="0">
+          <a:bodyPr wrap="square" lIns="0" rIns="0" tIns="0" bIns="0">
             <a:spAutoFit/>
           </a:bodyPr>
           <a:lstStyle/>
@@ -2835,7 +3381,6 @@
           <a:lstStyle/>
           <a:p>
             <a:pPr algn="ctr"/>
-            <a:endParaRPr/>
           </a:p>
         </p:txBody>
       </p:sp>
@@ -2856,7 +3401,7 @@
           <a:noFill/>
         </p:spPr>
         <p:txBody>
-          <a:bodyPr wrap="square" lIns="0" tIns="0" rIns="0" bIns="0">
+          <a:bodyPr wrap="square" lIns="0" rIns="0" tIns="0" bIns="0">
             <a:spAutoFit/>
           </a:bodyPr>
           <a:lstStyle/>
@@ -2885,7 +3430,7 @@
         </p:nvGraphicFramePr>
         <p:xfrm>
           <a:off x="822960" y="2011680"/>
-          <a:ext cx="10241280" cy="2750820"/>
+          <a:ext cx="10241280" cy="2560320"/>
         </p:xfrm>
         <a:graphic>
           <a:graphicData uri="http://schemas.openxmlformats.org/drawingml/2006/table">
@@ -2894,34 +3439,10 @@
                 <a:tableStyleId>{5C22544A-7EE6-4342-B048-85BDC9FD1C3A}</a:tableStyleId>
               </a:tblPr>
               <a:tblGrid>
-                <a:gridCol w="2560320">
-                  <a:extLst>
-                    <a:ext uri="{9D8B030D-6E8A-4147-A177-3AD203B41FA5}">
-                      <a16:colId xmlns:a16="http://schemas.microsoft.com/office/drawing/2014/main" val="20000"/>
-                    </a:ext>
-                  </a:extLst>
-                </a:gridCol>
-                <a:gridCol w="2560320">
-                  <a:extLst>
-                    <a:ext uri="{9D8B030D-6E8A-4147-A177-3AD203B41FA5}">
-                      <a16:colId xmlns:a16="http://schemas.microsoft.com/office/drawing/2014/main" val="20001"/>
-                    </a:ext>
-                  </a:extLst>
-                </a:gridCol>
-                <a:gridCol w="2560320">
-                  <a:extLst>
-                    <a:ext uri="{9D8B030D-6E8A-4147-A177-3AD203B41FA5}">
-                      <a16:colId xmlns:a16="http://schemas.microsoft.com/office/drawing/2014/main" val="20002"/>
-                    </a:ext>
-                  </a:extLst>
-                </a:gridCol>
-                <a:gridCol w="2560320">
-                  <a:extLst>
-                    <a:ext uri="{9D8B030D-6E8A-4147-A177-3AD203B41FA5}">
-                      <a16:colId xmlns:a16="http://schemas.microsoft.com/office/drawing/2014/main" val="20003"/>
-                    </a:ext>
-                  </a:extLst>
-                </a:gridCol>
+                <a:gridCol w="2560320"/>
+                <a:gridCol w="2560320"/>
+                <a:gridCol w="2560320"/>
+                <a:gridCol w="2560320"/>
               </a:tblGrid>
               <a:tr h="853440">
                 <a:tc>
@@ -3020,11 +3541,6 @@
                     </a:solidFill>
                   </a:tcPr>
                 </a:tc>
-                <a:extLst>
-                  <a:ext uri="{0D108BD9-81ED-4DB2-BD59-A6C34878D82A}">
-                    <a16:rowId xmlns:a16="http://schemas.microsoft.com/office/drawing/2014/main" val="10000"/>
-                  </a:ext>
-                </a:extLst>
               </a:tr>
               <a:tr h="853440">
                 <a:tc>
@@ -3123,11 +3639,6 @@
                     </a:solidFill>
                   </a:tcPr>
                 </a:tc>
-                <a:extLst>
-                  <a:ext uri="{0D108BD9-81ED-4DB2-BD59-A6C34878D82A}">
-                    <a16:rowId xmlns:a16="http://schemas.microsoft.com/office/drawing/2014/main" val="10001"/>
-                  </a:ext>
-                </a:extLst>
               </a:tr>
               <a:tr h="853440">
                 <a:tc>
@@ -3226,11 +3737,6 @@
                     </a:solidFill>
                   </a:tcPr>
                 </a:tc>
-                <a:extLst>
-                  <a:ext uri="{0D108BD9-81ED-4DB2-BD59-A6C34878D82A}">
-                    <a16:rowId xmlns:a16="http://schemas.microsoft.com/office/drawing/2014/main" val="10002"/>
-                  </a:ext>
-                </a:extLst>
               </a:tr>
             </a:tbl>
           </a:graphicData>
@@ -3274,7 +3780,7 @@
           </a:fontRef>
         </p:style>
         <p:txBody>
-          <a:bodyPr wrap="square" lIns="228600" tIns="228600" rIns="228600" bIns="228600" rtlCol="0" anchor="ctr"/>
+          <a:bodyPr rtlCol="0" anchor="ctr" wrap="square" lIns="228600" rIns="228600" tIns="228600" bIns="228600"/>
           <a:lstStyle/>
           <a:p>
             <a:pPr algn="ctr">
@@ -3289,62 +3795,8 @@
               </a:defRPr>
             </a:pPr>
             <a:r>
-              <a:rPr dirty="0"/>
-              <a:t>Minh </a:t>
-            </a:r>
-            <a:r>
-              <a:rPr dirty="0" err="1"/>
-              <a:t>chứng</a:t>
-            </a:r>
-            <a:r>
-              <a:rPr dirty="0"/>
-              <a:t> </a:t>
-            </a:r>
-            <a:r>
-              <a:rPr dirty="0" err="1"/>
-              <a:t>tích</a:t>
-            </a:r>
-            <a:r>
-              <a:rPr dirty="0"/>
-              <a:t> </a:t>
-            </a:r>
-            <a:r>
-              <a:rPr dirty="0" err="1"/>
-              <a:t>hợp</a:t>
-            </a:r>
-            <a:r>
-              <a:rPr dirty="0"/>
-              <a:t> &amp; </a:t>
-            </a:r>
-            <a:r>
-              <a:rPr dirty="0" err="1"/>
-              <a:t>Ứng</a:t>
-            </a:r>
-            <a:r>
-              <a:rPr dirty="0"/>
-              <a:t> </a:t>
-            </a:r>
-            <a:r>
-              <a:rPr dirty="0" err="1"/>
-              <a:t>dụng</a:t>
-            </a:r>
-            <a:r>
-              <a:rPr dirty="0"/>
-              <a:t> </a:t>
-            </a:r>
-            <a:r>
-              <a:rPr dirty="0" err="1"/>
-              <a:t>thực</a:t>
-            </a:r>
-            <a:r>
-              <a:rPr dirty="0"/>
-              <a:t> </a:t>
-            </a:r>
-            <a:r>
-              <a:rPr dirty="0" err="1"/>
-              <a:t>tiễn</a:t>
-            </a:r>
-            <a:endParaRPr dirty="0"/>
+              <a:t>Minh chứng tích hợp &amp; Ứng dụng thực tiễn</a:t>
+            </a:r>
           </a:p>
           <a:p>
             <a:pPr>
@@ -3359,184 +3811,7 @@
               </a:defRPr>
             </a:pPr>
             <a:r>
-              <a:rPr dirty="0"/>
-              <a:t>• </a:t>
-            </a:r>
-            <a:r>
-              <a:rPr dirty="0" err="1"/>
-              <a:t>Tích</a:t>
-            </a:r>
-            <a:r>
-              <a:rPr dirty="0"/>
-              <a:t> </a:t>
-            </a:r>
-            <a:r>
-              <a:rPr dirty="0" err="1"/>
-              <a:t>hợp</a:t>
-            </a:r>
-            <a:r>
-              <a:rPr dirty="0"/>
-              <a:t> </a:t>
-            </a:r>
-            <a:r>
-              <a:rPr dirty="0" err="1"/>
-              <a:t>PhoBERT</a:t>
-            </a:r>
-            <a:r>
-              <a:rPr dirty="0"/>
-              <a:t> </a:t>
-            </a:r>
-            <a:r>
-              <a:rPr dirty="0" err="1"/>
-              <a:t>đa</a:t>
-            </a:r>
-            <a:r>
-              <a:rPr dirty="0"/>
-              <a:t> </a:t>
-            </a:r>
-            <a:r>
-              <a:rPr dirty="0" err="1"/>
-              <a:t>tác</a:t>
-            </a:r>
-            <a:r>
-              <a:rPr dirty="0"/>
-              <a:t> </a:t>
-            </a:r>
-            <a:r>
-              <a:rPr dirty="0" err="1"/>
-              <a:t>vụ</a:t>
-            </a:r>
-            <a:r>
-              <a:rPr dirty="0"/>
-              <a:t> </a:t>
-            </a:r>
-            <a:r>
-              <a:rPr dirty="0" err="1"/>
-              <a:t>thành</a:t>
-            </a:r>
-            <a:r>
-              <a:rPr dirty="0"/>
-              <a:t> </a:t>
-            </a:r>
-            <a:r>
-              <a:rPr dirty="0" err="1"/>
-              <a:t>công</a:t>
-            </a:r>
-            <a:r>
-              <a:rPr dirty="0"/>
-              <a:t>: </a:t>
-            </a:r>
-            <a:r>
-              <a:rPr dirty="0" err="1"/>
-              <a:t>Mô</a:t>
-            </a:r>
-            <a:r>
-              <a:rPr dirty="0"/>
-              <a:t> </a:t>
-            </a:r>
-            <a:r>
-              <a:rPr dirty="0" err="1"/>
-              <a:t>hình</a:t>
-            </a:r>
-            <a:r>
-              <a:rPr dirty="0"/>
-              <a:t> </a:t>
-            </a:r>
-            <a:r>
-              <a:rPr dirty="0" err="1"/>
-              <a:t>tốt</a:t>
-            </a:r>
-            <a:r>
-              <a:rPr dirty="0"/>
-              <a:t> </a:t>
-            </a:r>
-            <a:r>
-              <a:rPr dirty="0" err="1"/>
-              <a:t>nhất</a:t>
-            </a:r>
-            <a:r>
-              <a:rPr dirty="0"/>
-              <a:t> </a:t>
-            </a:r>
-            <a:r>
-              <a:rPr dirty="0" err="1"/>
-              <a:t>đã</a:t>
-            </a:r>
-            <a:r>
-              <a:rPr dirty="0"/>
-              <a:t> </a:t>
-            </a:r>
-            <a:r>
-              <a:rPr dirty="0" err="1"/>
-              <a:t>được</a:t>
-            </a:r>
-            <a:r>
-              <a:rPr dirty="0"/>
-              <a:t> </a:t>
-            </a:r>
-            <a:r>
-              <a:rPr dirty="0" err="1"/>
-              <a:t>tích</a:t>
-            </a:r>
-            <a:r>
-              <a:rPr dirty="0"/>
-              <a:t> </a:t>
-            </a:r>
-            <a:r>
-              <a:rPr dirty="0" err="1"/>
-              <a:t>hợp</a:t>
-            </a:r>
-            <a:r>
-              <a:rPr dirty="0"/>
-              <a:t> </a:t>
-            </a:r>
-            <a:r>
-              <a:rPr dirty="0" err="1"/>
-              <a:t>chạy</a:t>
-            </a:r>
-            <a:r>
-              <a:rPr dirty="0"/>
-              <a:t> live </a:t>
-            </a:r>
-            <a:r>
-              <a:rPr dirty="0" err="1"/>
-              <a:t>mượt</a:t>
-            </a:r>
-            <a:r>
-              <a:rPr dirty="0"/>
-              <a:t> </a:t>
-            </a:r>
-            <a:r>
-              <a:rPr dirty="0" err="1"/>
-              <a:t>mà</a:t>
-            </a:r>
-            <a:r>
-              <a:rPr dirty="0"/>
-              <a:t> </a:t>
-            </a:r>
-            <a:r>
-              <a:rPr dirty="0" err="1"/>
-              <a:t>vào</a:t>
-            </a:r>
-            <a:r>
-              <a:rPr dirty="0"/>
-              <a:t> </a:t>
-            </a:r>
-            <a:r>
-              <a:rPr dirty="0" err="1"/>
-              <a:t>Streamlit</a:t>
-            </a:r>
-            <a:r>
-              <a:rPr dirty="0"/>
-              <a:t> Dashboard </a:t>
-            </a:r>
-            <a:r>
-              <a:rPr dirty="0" err="1"/>
-              <a:t>và</a:t>
-            </a:r>
-            <a:r>
-              <a:rPr dirty="0"/>
-              <a:t> Flask API.</a:t>
+              <a:t>• Tích hợp PhoBERT đa tác vụ thành công: Mô hình tốt nhất đã được tích hợp chạy live mượt mà vào Streamlit Dashboard và Flask API.</a:t>
             </a:r>
           </a:p>
           <a:p>
@@ -3552,264 +3827,7 @@
               </a:defRPr>
             </a:pPr>
             <a:r>
-              <a:rPr dirty="0"/>
-              <a:t>• Giao </a:t>
-            </a:r>
-            <a:r>
-              <a:rPr dirty="0" err="1"/>
-              <a:t>diện</a:t>
-            </a:r>
-            <a:r>
-              <a:rPr dirty="0"/>
-              <a:t> dashboard </a:t>
-            </a:r>
-            <a:r>
-              <a:rPr dirty="0" err="1"/>
-              <a:t>tương</a:t>
-            </a:r>
-            <a:r>
-              <a:rPr dirty="0"/>
-              <a:t> </a:t>
-            </a:r>
-            <a:r>
-              <a:rPr dirty="0" err="1"/>
-              <a:t>tác</a:t>
-            </a:r>
-            <a:r>
-              <a:rPr dirty="0"/>
-              <a:t> </a:t>
-            </a:r>
-            <a:r>
-              <a:rPr dirty="0" err="1"/>
-              <a:t>trực</a:t>
-            </a:r>
-            <a:r>
-              <a:rPr dirty="0"/>
-              <a:t> </a:t>
-            </a:r>
-            <a:r>
-              <a:rPr dirty="0" err="1"/>
-              <a:t>quan</a:t>
-            </a:r>
-            <a:r>
-              <a:rPr dirty="0"/>
-              <a:t>: Cho </a:t>
-            </a:r>
-            <a:r>
-              <a:rPr dirty="0" err="1"/>
-              <a:t>phép</a:t>
-            </a:r>
-            <a:r>
-              <a:rPr dirty="0"/>
-              <a:t> </a:t>
-            </a:r>
-            <a:r>
-              <a:rPr dirty="0" err="1"/>
-              <a:t>lọc</a:t>
-            </a:r>
-            <a:r>
-              <a:rPr dirty="0"/>
-              <a:t> </a:t>
-            </a:r>
-            <a:r>
-              <a:rPr dirty="0" err="1"/>
-              <a:t>theo</a:t>
-            </a:r>
-            <a:r>
-              <a:rPr dirty="0"/>
-              <a:t> </a:t>
-            </a:r>
-            <a:r>
-              <a:rPr dirty="0" err="1"/>
-              <a:t>khía</a:t>
-            </a:r>
-            <a:r>
-              <a:rPr dirty="0"/>
-              <a:t> </a:t>
-            </a:r>
-            <a:r>
-              <a:rPr dirty="0" err="1"/>
-              <a:t>cạnh</a:t>
-            </a:r>
-            <a:r>
-              <a:rPr dirty="0"/>
-              <a:t>, </a:t>
-            </a:r>
-            <a:r>
-              <a:rPr dirty="0" err="1"/>
-              <a:t>lọc</a:t>
-            </a:r>
-            <a:r>
-              <a:rPr dirty="0"/>
-              <a:t> </a:t>
-            </a:r>
-            <a:r>
-              <a:rPr dirty="0" err="1"/>
-              <a:t>mức</a:t>
-            </a:r>
-            <a:r>
-              <a:rPr dirty="0"/>
-              <a:t> </a:t>
-            </a:r>
-            <a:r>
-              <a:rPr dirty="0" err="1"/>
-              <a:t>độ</a:t>
-            </a:r>
-            <a:r>
-              <a:rPr dirty="0"/>
-              <a:t> </a:t>
-            </a:r>
-            <a:r>
-              <a:rPr dirty="0" err="1"/>
-              <a:t>ưu</a:t>
-            </a:r>
-            <a:r>
-              <a:rPr dirty="0"/>
-              <a:t> </a:t>
-            </a:r>
-            <a:r>
-              <a:rPr dirty="0" err="1"/>
-              <a:t>tiên</a:t>
-            </a:r>
-            <a:r>
-              <a:rPr dirty="0"/>
-              <a:t> (</a:t>
-            </a:r>
-            <a:r>
-              <a:rPr dirty="0" err="1"/>
-              <a:t>Cảnh</a:t>
-            </a:r>
-            <a:r>
-              <a:rPr dirty="0"/>
-              <a:t> </a:t>
-            </a:r>
-            <a:r>
-              <a:rPr dirty="0" err="1"/>
-              <a:t>báo</a:t>
-            </a:r>
-            <a:r>
-              <a:rPr dirty="0"/>
-              <a:t> </a:t>
-            </a:r>
-            <a:r>
-              <a:rPr dirty="0" err="1"/>
-              <a:t>ưu</a:t>
-            </a:r>
-            <a:r>
-              <a:rPr dirty="0"/>
-              <a:t> </a:t>
-            </a:r>
-            <a:r>
-              <a:rPr dirty="0" err="1"/>
-              <a:t>tiên</a:t>
-            </a:r>
-            <a:r>
-              <a:rPr dirty="0"/>
-              <a:t> </a:t>
-            </a:r>
-            <a:r>
-              <a:rPr dirty="0" err="1"/>
-              <a:t>cao</a:t>
-            </a:r>
-            <a:r>
-              <a:rPr dirty="0"/>
-              <a:t>), </a:t>
-            </a:r>
-            <a:r>
-              <a:rPr dirty="0" err="1"/>
-              <a:t>phân</a:t>
-            </a:r>
-            <a:r>
-              <a:rPr dirty="0"/>
-              <a:t> </a:t>
-            </a:r>
-            <a:r>
-              <a:rPr dirty="0" err="1"/>
-              <a:t>tích</a:t>
-            </a:r>
-            <a:r>
-              <a:rPr dirty="0"/>
-              <a:t> </a:t>
-            </a:r>
-            <a:r>
-              <a:rPr dirty="0" err="1"/>
-              <a:t>phân</a:t>
-            </a:r>
-            <a:r>
-              <a:rPr dirty="0"/>
-              <a:t> </a:t>
-            </a:r>
-            <a:r>
-              <a:rPr dirty="0" err="1"/>
-              <a:t>bố</a:t>
-            </a:r>
-            <a:r>
-              <a:rPr dirty="0"/>
-              <a:t> </a:t>
-            </a:r>
-            <a:r>
-              <a:rPr dirty="0" err="1"/>
-              <a:t>eWOM</a:t>
-            </a:r>
-            <a:r>
-              <a:rPr dirty="0"/>
-              <a:t> </a:t>
-            </a:r>
-            <a:r>
-              <a:rPr dirty="0" err="1"/>
-              <a:t>và</a:t>
-            </a:r>
-            <a:r>
-              <a:rPr dirty="0"/>
-              <a:t> </a:t>
-            </a:r>
-            <a:r>
-              <a:rPr dirty="0" err="1"/>
-              <a:t>chiến</a:t>
-            </a:r>
-            <a:r>
-              <a:rPr dirty="0"/>
-              <a:t> </a:t>
-            </a:r>
-            <a:r>
-              <a:rPr dirty="0" err="1"/>
-              <a:t>lược</a:t>
-            </a:r>
-            <a:r>
-              <a:rPr dirty="0"/>
-              <a:t> RACE </a:t>
-            </a:r>
-            <a:r>
-              <a:rPr dirty="0" err="1"/>
-              <a:t>theo</a:t>
-            </a:r>
-            <a:r>
-              <a:rPr dirty="0"/>
-              <a:t> </a:t>
-            </a:r>
-            <a:r>
-              <a:rPr dirty="0" err="1"/>
-              <a:t>thời</a:t>
-            </a:r>
-            <a:r>
-              <a:rPr dirty="0"/>
-              <a:t> </a:t>
-            </a:r>
-            <a:r>
-              <a:rPr dirty="0" err="1"/>
-              <a:t>gian</a:t>
-            </a:r>
-            <a:r>
-              <a:rPr dirty="0"/>
-              <a:t> </a:t>
-            </a:r>
-            <a:r>
-              <a:rPr dirty="0" err="1"/>
-              <a:t>thực</a:t>
-            </a:r>
-            <a:r>
-              <a:rPr dirty="0"/>
-              <a:t>.</a:t>
+              <a:t>• Giao diện dashboard tương tác trực quan: Cho phép lọc theo khía cạnh, lọc mức độ ưu tiên (Cảnh báo ưu tiên cao), phân tích phân bố eWOM và chiến lược RACE theo thời gian thực.</a:t>
             </a:r>
           </a:p>
           <a:p>
@@ -3825,303 +3843,14 @@
               </a:defRPr>
             </a:pPr>
             <a:r>
-              <a:rPr dirty="0"/>
-              <a:t>• </a:t>
-            </a:r>
-            <a:r>
-              <a:rPr dirty="0" err="1"/>
-              <a:t>Tải</a:t>
-            </a:r>
-            <a:r>
-              <a:rPr dirty="0"/>
-              <a:t> </a:t>
-            </a:r>
-            <a:r>
-              <a:rPr dirty="0" err="1"/>
-              <a:t>trước</a:t>
-            </a:r>
-            <a:r>
-              <a:rPr dirty="0"/>
-              <a:t> </a:t>
-            </a:r>
-            <a:r>
-              <a:rPr dirty="0" err="1"/>
-              <a:t>dữ</a:t>
-            </a:r>
-            <a:r>
-              <a:rPr dirty="0"/>
-              <a:t> </a:t>
-            </a:r>
-            <a:r>
-              <a:rPr dirty="0" err="1"/>
-              <a:t>liệu</a:t>
-            </a:r>
-            <a:r>
-              <a:rPr dirty="0"/>
-              <a:t> (Pre-predicted): </a:t>
-            </a:r>
-            <a:r>
-              <a:rPr dirty="0" err="1"/>
-              <a:t>Tích</a:t>
-            </a:r>
-            <a:r>
-              <a:rPr dirty="0"/>
-              <a:t> </a:t>
-            </a:r>
-            <a:r>
-              <a:rPr dirty="0" err="1"/>
-              <a:t>hợp</a:t>
-            </a:r>
-            <a:r>
-              <a:rPr dirty="0"/>
-              <a:t> </a:t>
-            </a:r>
-            <a:r>
-              <a:rPr dirty="0" err="1"/>
-              <a:t>tính</a:t>
-            </a:r>
-            <a:r>
-              <a:rPr dirty="0"/>
-              <a:t> </a:t>
-            </a:r>
-            <a:r>
-              <a:rPr dirty="0" err="1"/>
-              <a:t>năng</a:t>
-            </a:r>
-            <a:r>
-              <a:rPr dirty="0"/>
-              <a:t> load </a:t>
-            </a:r>
-            <a:r>
-              <a:rPr dirty="0" err="1"/>
-              <a:t>dữ</a:t>
-            </a:r>
-            <a:r>
-              <a:rPr dirty="0"/>
-              <a:t> </a:t>
-            </a:r>
-            <a:r>
-              <a:rPr dirty="0" err="1"/>
-              <a:t>liệu</a:t>
-            </a:r>
-            <a:r>
-              <a:rPr dirty="0"/>
-              <a:t> </a:t>
-            </a:r>
-            <a:r>
-              <a:rPr dirty="0" err="1"/>
-              <a:t>đã</a:t>
-            </a:r>
-            <a:r>
-              <a:rPr dirty="0"/>
-              <a:t> </a:t>
-            </a:r>
-            <a:r>
-              <a:rPr dirty="0" err="1"/>
-              <a:t>dự</a:t>
-            </a:r>
-            <a:r>
-              <a:rPr dirty="0"/>
-              <a:t> </a:t>
-            </a:r>
-            <a:r>
-              <a:rPr dirty="0" err="1"/>
-              <a:t>đoán</a:t>
-            </a:r>
-            <a:r>
-              <a:rPr dirty="0"/>
-              <a:t> </a:t>
-            </a:r>
-            <a:r>
-              <a:rPr dirty="0" err="1"/>
-              <a:t>sẵn</a:t>
-            </a:r>
-            <a:r>
-              <a:rPr dirty="0"/>
-              <a:t> (100k </a:t>
-            </a:r>
-            <a:r>
-              <a:rPr dirty="0" err="1"/>
-              <a:t>dòng</a:t>
-            </a:r>
-            <a:r>
-              <a:rPr dirty="0"/>
-              <a:t>) </a:t>
-            </a:r>
-            <a:r>
-              <a:rPr dirty="0" err="1"/>
-              <a:t>chỉ</a:t>
-            </a:r>
-            <a:r>
-              <a:rPr dirty="0"/>
-              <a:t> </a:t>
-            </a:r>
-            <a:r>
-              <a:rPr dirty="0" err="1"/>
-              <a:t>trong</a:t>
-            </a:r>
-            <a:r>
-              <a:rPr dirty="0"/>
-              <a:t> 1 </a:t>
-            </a:r>
-            <a:r>
-              <a:rPr dirty="0" err="1"/>
-              <a:t>giây</a:t>
-            </a:r>
-            <a:r>
-              <a:rPr dirty="0"/>
-              <a:t> </a:t>
-            </a:r>
-            <a:r>
-              <a:rPr dirty="0" err="1"/>
-              <a:t>trên</a:t>
-            </a:r>
-            <a:r>
-              <a:rPr dirty="0"/>
-              <a:t> dashboard </a:t>
-            </a:r>
-            <a:r>
-              <a:rPr dirty="0" err="1"/>
-              <a:t>để</a:t>
-            </a:r>
-            <a:r>
-              <a:rPr dirty="0"/>
-              <a:t> </a:t>
-            </a:r>
-            <a:r>
-              <a:rPr dirty="0" err="1"/>
-              <a:t>tối</a:t>
-            </a:r>
-            <a:r>
-              <a:rPr dirty="0"/>
-              <a:t> </a:t>
-            </a:r>
-            <a:r>
-              <a:rPr dirty="0" err="1"/>
-              <a:t>ưu</a:t>
-            </a:r>
-            <a:r>
-              <a:rPr dirty="0"/>
-              <a:t> </a:t>
-            </a:r>
-            <a:r>
-              <a:rPr dirty="0" err="1"/>
-              <a:t>trải</a:t>
-            </a:r>
-            <a:r>
-              <a:rPr dirty="0"/>
-              <a:t> </a:t>
-            </a:r>
-            <a:r>
-              <a:rPr dirty="0" err="1"/>
-              <a:t>nghiệm</a:t>
-            </a:r>
-            <a:r>
-              <a:rPr dirty="0"/>
-              <a:t> </a:t>
-            </a:r>
-            <a:r>
-              <a:rPr dirty="0" err="1"/>
-              <a:t>người</a:t>
-            </a:r>
-            <a:r>
-              <a:rPr dirty="0"/>
-              <a:t> </a:t>
-            </a:r>
-            <a:r>
-              <a:rPr dirty="0" err="1"/>
-              <a:t>dùng</a:t>
-            </a:r>
-            <a:r>
-              <a:rPr dirty="0"/>
-              <a:t>, </a:t>
-            </a:r>
-            <a:r>
-              <a:rPr dirty="0" err="1"/>
-              <a:t>đồng</a:t>
-            </a:r>
-            <a:r>
-              <a:rPr dirty="0"/>
-              <a:t> </a:t>
-            </a:r>
-            <a:r>
-              <a:rPr dirty="0" err="1"/>
-              <a:t>thời</a:t>
-            </a:r>
-            <a:r>
-              <a:rPr dirty="0"/>
-              <a:t> </a:t>
-            </a:r>
-            <a:r>
-              <a:rPr dirty="0" err="1"/>
-              <a:t>hỗ</a:t>
-            </a:r>
-            <a:r>
-              <a:rPr dirty="0"/>
-              <a:t> </a:t>
-            </a:r>
-            <a:r>
-              <a:rPr dirty="0" err="1"/>
-              <a:t>trợ</a:t>
-            </a:r>
-            <a:r>
-              <a:rPr dirty="0"/>
-              <a:t> </a:t>
-            </a:r>
-            <a:r>
-              <a:rPr dirty="0" err="1"/>
-              <a:t>dự</a:t>
-            </a:r>
-            <a:r>
-              <a:rPr dirty="0"/>
-              <a:t> </a:t>
-            </a:r>
-            <a:r>
-              <a:rPr dirty="0" err="1"/>
-              <a:t>đoán</a:t>
-            </a:r>
-            <a:r>
-              <a:rPr dirty="0"/>
-              <a:t> </a:t>
-            </a:r>
-            <a:r>
-              <a:rPr dirty="0" err="1"/>
-              <a:t>trực</a:t>
-            </a:r>
-            <a:r>
-              <a:rPr dirty="0"/>
-              <a:t> </a:t>
-            </a:r>
-            <a:r>
-              <a:rPr dirty="0" err="1"/>
-              <a:t>tiếp</a:t>
-            </a:r>
-            <a:r>
-              <a:rPr dirty="0"/>
-              <a:t> real-time </a:t>
-            </a:r>
-            <a:r>
-              <a:rPr dirty="0" err="1"/>
-              <a:t>cho</a:t>
-            </a:r>
-            <a:r>
-              <a:rPr dirty="0"/>
-              <a:t> review </a:t>
-            </a:r>
-            <a:r>
-              <a:rPr dirty="0" err="1"/>
-              <a:t>mới</a:t>
-            </a:r>
-            <a:r>
-              <a:rPr dirty="0"/>
-              <a:t>.</a:t>
+              <a:t>• Tải trước dữ liệu (Pre-predicted): Tích hợp tính năng load dữ liệu đã dự đoán sẵn (100k dòng) chỉ trong 1 giây trên dashboard để tối ưu trải nghiệm người dùng, đồng thời hỗ trợ dự đoán trực tiếp real-time cho review mới.</a:t>
             </a:r>
           </a:p>
         </p:txBody>
       </p:sp>
       <p:pic>
         <p:nvPicPr>
-          <p:cNvPr id="7" name="Picture 6" descr="anh_3.png"/>
+          <p:cNvPr id="7" name="Picture 6" descr="image.png"/>
           <p:cNvPicPr>
             <a:picLocks noChangeAspect="1"/>
           </p:cNvPicPr>
@@ -4135,8 +3864,8 @@
         </p:blipFill>
         <p:spPr>
           <a:xfrm>
-            <a:off x="11218460" y="2011680"/>
-            <a:ext cx="6687403" cy="5985908"/>
+            <a:off x="11521440" y="2011680"/>
+            <a:ext cx="5943600" cy="7589520"/>
           </a:xfrm>
           <a:prstGeom prst="rect">
             <a:avLst/>
@@ -4185,7 +3914,7 @@
           <a:noFill/>
         </p:spPr>
         <p:txBody>
-          <a:bodyPr wrap="square" lIns="0" tIns="0" rIns="0" bIns="0">
+          <a:bodyPr wrap="square" lIns="0" rIns="0" tIns="0" bIns="0">
             <a:spAutoFit/>
           </a:bodyPr>
           <a:lstStyle/>
@@ -4246,7 +3975,6 @@
           <a:lstStyle/>
           <a:p>
             <a:pPr algn="ctr"/>
-            <a:endParaRPr/>
           </a:p>
         </p:txBody>
       </p:sp>
@@ -4267,7 +3995,7 @@
           <a:noFill/>
         </p:spPr>
         <p:txBody>
-          <a:bodyPr wrap="square" lIns="0" tIns="0" rIns="0" bIns="0">
+          <a:bodyPr wrap="square" lIns="0" rIns="0" tIns="0" bIns="0">
             <a:spAutoFit/>
           </a:bodyPr>
           <a:lstStyle/>
@@ -4296,7 +4024,7 @@
         </p:nvGraphicFramePr>
         <p:xfrm>
           <a:off x="822960" y="2011680"/>
-          <a:ext cx="10241280" cy="3924300"/>
+          <a:ext cx="10241280" cy="3657600"/>
         </p:xfrm>
         <a:graphic>
           <a:graphicData uri="http://schemas.openxmlformats.org/drawingml/2006/table">
@@ -4305,34 +4033,10 @@
                 <a:tableStyleId>{5C22544A-7EE6-4342-B048-85BDC9FD1C3A}</a:tableStyleId>
               </a:tblPr>
               <a:tblGrid>
-                <a:gridCol w="2560320">
-                  <a:extLst>
-                    <a:ext uri="{9D8B030D-6E8A-4147-A177-3AD203B41FA5}">
-                      <a16:colId xmlns:a16="http://schemas.microsoft.com/office/drawing/2014/main" val="20000"/>
-                    </a:ext>
-                  </a:extLst>
-                </a:gridCol>
-                <a:gridCol w="2560320">
-                  <a:extLst>
-                    <a:ext uri="{9D8B030D-6E8A-4147-A177-3AD203B41FA5}">
-                      <a16:colId xmlns:a16="http://schemas.microsoft.com/office/drawing/2014/main" val="20001"/>
-                    </a:ext>
-                  </a:extLst>
-                </a:gridCol>
-                <a:gridCol w="2560320">
-                  <a:extLst>
-                    <a:ext uri="{9D8B030D-6E8A-4147-A177-3AD203B41FA5}">
-                      <a16:colId xmlns:a16="http://schemas.microsoft.com/office/drawing/2014/main" val="20002"/>
-                    </a:ext>
-                  </a:extLst>
-                </a:gridCol>
-                <a:gridCol w="2560320">
-                  <a:extLst>
-                    <a:ext uri="{9D8B030D-6E8A-4147-A177-3AD203B41FA5}">
-                      <a16:colId xmlns:a16="http://schemas.microsoft.com/office/drawing/2014/main" val="20003"/>
-                    </a:ext>
-                  </a:extLst>
-                </a:gridCol>
+                <a:gridCol w="2560320"/>
+                <a:gridCol w="2560320"/>
+                <a:gridCol w="2560320"/>
+                <a:gridCol w="2560320"/>
               </a:tblGrid>
               <a:tr h="609600">
                 <a:tc>
@@ -4431,11 +4135,6 @@
                     </a:solidFill>
                   </a:tcPr>
                 </a:tc>
-                <a:extLst>
-                  <a:ext uri="{0D108BD9-81ED-4DB2-BD59-A6C34878D82A}">
-                    <a16:rowId xmlns:a16="http://schemas.microsoft.com/office/drawing/2014/main" val="10000"/>
-                  </a:ext>
-                </a:extLst>
               </a:tr>
               <a:tr h="609600">
                 <a:tc>
@@ -4534,11 +4233,6 @@
                     </a:solidFill>
                   </a:tcPr>
                 </a:tc>
-                <a:extLst>
-                  <a:ext uri="{0D108BD9-81ED-4DB2-BD59-A6C34878D82A}">
-                    <a16:rowId xmlns:a16="http://schemas.microsoft.com/office/drawing/2014/main" val="10001"/>
-                  </a:ext>
-                </a:extLst>
               </a:tr>
               <a:tr h="609600">
                 <a:tc>
@@ -4603,7 +4297,7 @@
                         </a:defRPr>
                       </a:pPr>
                       <a:r>
-                        <a:t>~2,000,000 dòng dữ liệu thô lớn</a:t>
+                        <a:t>~1.300.000 dòng dữ liệu thô lớn</a:t>
                       </a:r>
                     </a:p>
                   </a:txBody>
@@ -4637,11 +4331,6 @@
                     </a:solidFill>
                   </a:tcPr>
                 </a:tc>
-                <a:extLst>
-                  <a:ext uri="{0D108BD9-81ED-4DB2-BD59-A6C34878D82A}">
-                    <a16:rowId xmlns:a16="http://schemas.microsoft.com/office/drawing/2014/main" val="10002"/>
-                  </a:ext>
-                </a:extLst>
               </a:tr>
               <a:tr h="609600">
                 <a:tc>
@@ -4740,11 +4429,6 @@
                     </a:solidFill>
                   </a:tcPr>
                 </a:tc>
-                <a:extLst>
-                  <a:ext uri="{0D108BD9-81ED-4DB2-BD59-A6C34878D82A}">
-                    <a16:rowId xmlns:a16="http://schemas.microsoft.com/office/drawing/2014/main" val="10003"/>
-                  </a:ext>
-                </a:extLst>
               </a:tr>
               <a:tr h="609600">
                 <a:tc>
@@ -4843,11 +4527,6 @@
                     </a:solidFill>
                   </a:tcPr>
                 </a:tc>
-                <a:extLst>
-                  <a:ext uri="{0D108BD9-81ED-4DB2-BD59-A6C34878D82A}">
-                    <a16:rowId xmlns:a16="http://schemas.microsoft.com/office/drawing/2014/main" val="10004"/>
-                  </a:ext>
-                </a:extLst>
               </a:tr>
               <a:tr h="609600">
                 <a:tc>
@@ -4946,11 +4625,6 @@
                     </a:solidFill>
                   </a:tcPr>
                 </a:tc>
-                <a:extLst>
-                  <a:ext uri="{0D108BD9-81ED-4DB2-BD59-A6C34878D82A}">
-                    <a16:rowId xmlns:a16="http://schemas.microsoft.com/office/drawing/2014/main" val="10005"/>
-                  </a:ext>
-                </a:extLst>
               </a:tr>
             </a:tbl>
           </a:graphicData>
@@ -4994,7 +4668,7 @@
           </a:fontRef>
         </p:style>
         <p:txBody>
-          <a:bodyPr wrap="square" lIns="228600" tIns="228600" rIns="228600" bIns="228600" rtlCol="0" anchor="ctr"/>
+          <a:bodyPr rtlCol="0" anchor="ctr" wrap="square" lIns="228600" rIns="228600" tIns="228600" bIns="228600"/>
           <a:lstStyle/>
           <a:p>
             <a:pPr algn="ctr">
@@ -5104,7 +4778,6 @@
           <a:lstStyle/>
           <a:p>
             <a:pPr algn="ctr"/>
-            <a:endParaRPr/>
           </a:p>
         </p:txBody>
       </p:sp>
@@ -5125,13 +4798,13 @@
           <a:noFill/>
         </p:spPr>
         <p:txBody>
-          <a:bodyPr wrap="square" lIns="0" tIns="0" rIns="0" bIns="0">
+          <a:bodyPr wrap="square" lIns="0" rIns="0" tIns="0" bIns="0">
             <a:spAutoFit/>
           </a:bodyPr>
           <a:lstStyle/>
           <a:p>
             <a:pPr algn="ctr">
-              <a:defRPr sz="1400" b="1">
+              <a:defRPr b="1" sz="1400">
                 <a:solidFill>
                   <a:srgbClr val="0E8C61"/>
                 </a:solidFill>
@@ -5182,7 +4855,7 @@
           </a:fontRef>
         </p:style>
         <p:txBody>
-          <a:bodyPr wrap="square" lIns="137160" tIns="73152" rIns="137160" bIns="73152" rtlCol="0" anchor="ctr"/>
+          <a:bodyPr rtlCol="0" anchor="ctr" wrap="square" lIns="137160" rIns="137160" tIns="73152" bIns="73152"/>
           <a:lstStyle/>
           <a:p>
             <a:pPr algn="ctr">
@@ -5210,7 +4883,7 @@
               </a:defRPr>
             </a:pPr>
             <a:r>
-              <a:t>• Tích lũy ~2,000,000 dòng đánh giá Shopee/Tiki/Lazada</a:t>
+              <a:t>• Tích lũy ~1,300,000 dòng đánh giá Shopee/Tiki/Lazada</a:t>
             </a:r>
           </a:p>
         </p:txBody>
@@ -5257,7 +4930,6 @@
           <a:lstStyle/>
           <a:p>
             <a:pPr algn="ctr"/>
-            <a:endParaRPr/>
           </a:p>
         </p:txBody>
       </p:sp>
@@ -5299,7 +4971,7 @@
           </a:fontRef>
         </p:style>
         <p:txBody>
-          <a:bodyPr wrap="square" lIns="137160" tIns="73152" rIns="137160" bIns="73152" rtlCol="0" anchor="ctr"/>
+          <a:bodyPr rtlCol="0" anchor="ctr" wrap="square" lIns="137160" rIns="137160" tIns="73152" bIns="73152"/>
           <a:lstStyle/>
           <a:p>
             <a:pPr algn="ctr">
@@ -5374,7 +5046,6 @@
           <a:lstStyle/>
           <a:p>
             <a:pPr algn="ctr"/>
-            <a:endParaRPr/>
           </a:p>
         </p:txBody>
       </p:sp>
@@ -5416,7 +5087,7 @@
           </a:fontRef>
         </p:style>
         <p:txBody>
-          <a:bodyPr wrap="square" lIns="137160" tIns="73152" rIns="137160" bIns="73152" rtlCol="0" anchor="ctr"/>
+          <a:bodyPr rtlCol="0" anchor="ctr" wrap="square" lIns="137160" rIns="137160" tIns="73152" bIns="73152"/>
           <a:lstStyle/>
           <a:p>
             <a:pPr algn="ctr">
@@ -5444,7 +5115,7 @@
               </a:defRPr>
             </a:pPr>
             <a:r>
-              <a:t>• Phân chia tập huấn luyện Working Train (779) &amp; Gold Eval (250)</a:t>
+              <a:t>• Phân chia tập huấn luyện Working Train (308) &amp; Gold Eval (721)</a:t>
             </a:r>
           </a:p>
         </p:txBody>
@@ -5491,7 +5162,6 @@
           <a:lstStyle/>
           <a:p>
             <a:pPr algn="ctr"/>
-            <a:endParaRPr/>
           </a:p>
         </p:txBody>
       </p:sp>
@@ -5533,7 +5203,7 @@
           </a:fontRef>
         </p:style>
         <p:txBody>
-          <a:bodyPr wrap="square" lIns="137160" tIns="73152" rIns="137160" bIns="73152" rtlCol="0" anchor="ctr"/>
+          <a:bodyPr rtlCol="0" anchor="ctr" wrap="square" lIns="137160" rIns="137160" tIns="73152" bIns="73152"/>
           <a:lstStyle/>
           <a:p>
             <a:pPr algn="ctr">
@@ -5545,58 +5215,8 @@
               </a:defRPr>
             </a:pPr>
             <a:r>
-              <a:rPr dirty="0" err="1"/>
-              <a:t>Bước</a:t>
-            </a:r>
-            <a:r>
-              <a:rPr dirty="0"/>
-              <a:t> 4: </a:t>
-            </a:r>
-            <a:r>
-              <a:rPr dirty="0" err="1"/>
-              <a:t>Huấn</a:t>
-            </a:r>
-            <a:r>
-              <a:rPr dirty="0"/>
-              <a:t> </a:t>
-            </a:r>
-            <a:r>
-              <a:rPr dirty="0" err="1"/>
-              <a:t>luyện</a:t>
-            </a:r>
-            <a:r>
-              <a:rPr dirty="0"/>
-              <a:t> </a:t>
-            </a:r>
-            <a:r>
-              <a:rPr dirty="0" err="1"/>
-              <a:t>Mô</a:t>
-            </a:r>
-            <a:r>
-              <a:rPr dirty="0"/>
-              <a:t> </a:t>
-            </a:r>
-            <a:r>
-              <a:rPr dirty="0" err="1"/>
-              <a:t>hình</a:t>
-            </a:r>
-            <a:r>
-              <a:rPr dirty="0"/>
-              <a:t> ABSA </a:t>
-            </a:r>
-            <a:r>
-              <a:rPr dirty="0" err="1"/>
-              <a:t>Đa</a:t>
-            </a:r>
-            <a:r>
-              <a:rPr dirty="0"/>
-              <a:t> </a:t>
-            </a:r>
-            <a:r>
-              <a:rPr dirty="0" err="1"/>
-              <a:t>nhiệm</a:t>
-            </a:r>
-            <a:endParaRPr dirty="0"/>
+              <a:t>Bước 4: Huấn luyện Mô hình ABSA Đa nhiệm</a:t>
+            </a:r>
           </a:p>
           <a:p>
             <a:pPr>
@@ -5611,38 +5231,8 @@
               </a:defRPr>
             </a:pPr>
             <a:r>
-              <a:rPr dirty="0"/>
-              <a:t>• Fine-tuned </a:t>
-            </a:r>
-            <a:r>
-              <a:rPr dirty="0" err="1"/>
-              <a:t>PhoBERT</a:t>
-            </a:r>
-            <a:r>
-              <a:rPr dirty="0"/>
-              <a:t> </a:t>
-            </a:r>
-            <a:r>
-              <a:rPr dirty="0" err="1"/>
-              <a:t>PyTorch</a:t>
-            </a:r>
-            <a:r>
-              <a:rPr dirty="0"/>
-              <a:t> </a:t>
-            </a:r>
-            <a:r>
-              <a:rPr dirty="0" err="1"/>
-              <a:t>trên</a:t>
-            </a:r>
-            <a:r>
-              <a:rPr dirty="0"/>
-              <a:t> Kaggle GPU T4 song </a:t>
-            </a:r>
-            <a:r>
-              <a:rPr dirty="0" err="1"/>
-              <a:t>song</a:t>
-            </a:r>
-            <a:endParaRPr dirty="0"/>
+              <a:t>• Fine-tuned PhoBERT PyTorch trên Kaggle GPU T4 song song</a:t>
+            </a:r>
           </a:p>
         </p:txBody>
       </p:sp>
@@ -5688,7 +5278,6 @@
           <a:lstStyle/>
           <a:p>
             <a:pPr algn="ctr"/>
-            <a:endParaRPr/>
           </a:p>
         </p:txBody>
       </p:sp>
@@ -5730,7 +5319,7 @@
           </a:fontRef>
         </p:style>
         <p:txBody>
-          <a:bodyPr wrap="square" lIns="137160" tIns="73152" rIns="137160" bIns="73152" rtlCol="0" anchor="ctr"/>
+          <a:bodyPr rtlCol="0" anchor="ctr" wrap="square" lIns="137160" rIns="137160" tIns="73152" bIns="73152"/>
           <a:lstStyle/>
           <a:p>
             <a:pPr algn="ctr">
@@ -5742,44 +5331,7 @@
               </a:defRPr>
             </a:pPr>
             <a:r>
-              <a:rPr dirty="0" err="1"/>
-              <a:t>Bước</a:t>
-            </a:r>
-            <a:r>
-              <a:rPr dirty="0"/>
-              <a:t> 5: API &amp; </a:t>
-            </a:r>
-            <a:r>
-              <a:rPr dirty="0" err="1"/>
-              <a:t>Dự</a:t>
-            </a:r>
-            <a:r>
-              <a:rPr dirty="0"/>
-              <a:t> </a:t>
-            </a:r>
-            <a:r>
-              <a:rPr dirty="0" err="1"/>
-              <a:t>đoán</a:t>
-            </a:r>
-            <a:r>
-              <a:rPr dirty="0"/>
-              <a:t> </a:t>
-            </a:r>
-            <a:r>
-              <a:rPr dirty="0" err="1"/>
-              <a:t>hàng</a:t>
-            </a:r>
-            <a:r>
-              <a:rPr dirty="0"/>
-              <a:t> </a:t>
-            </a:r>
-            <a:r>
-              <a:rPr dirty="0" err="1"/>
-              <a:t>loạt</a:t>
-            </a:r>
-            <a:r>
-              <a:rPr dirty="0"/>
-              <a:t> (Flask)</a:t>
+              <a:t>Bước 5: API &amp; Dự đoán hàng loạt (Flask)</a:t>
             </a:r>
           </a:p>
           <a:p>
@@ -5795,70 +5347,8 @@
               </a:defRPr>
             </a:pPr>
             <a:r>
-              <a:rPr dirty="0"/>
-              <a:t>• </a:t>
-            </a:r>
-            <a:r>
-              <a:rPr dirty="0" err="1"/>
-              <a:t>Đóng</a:t>
-            </a:r>
-            <a:r>
-              <a:rPr dirty="0"/>
-              <a:t> </a:t>
-            </a:r>
-            <a:r>
-              <a:rPr dirty="0" err="1"/>
-              <a:t>gói</a:t>
-            </a:r>
-            <a:r>
-              <a:rPr dirty="0"/>
-              <a:t> Flask API, </a:t>
-            </a:r>
-            <a:r>
-              <a:rPr dirty="0" err="1"/>
-              <a:t>dự</a:t>
-            </a:r>
-            <a:r>
-              <a:rPr dirty="0"/>
-              <a:t> </a:t>
-            </a:r>
-            <a:r>
-              <a:rPr dirty="0" err="1"/>
-              <a:t>đoán</a:t>
-            </a:r>
-            <a:r>
-              <a:rPr dirty="0"/>
-              <a:t> </a:t>
-            </a:r>
-            <a:r>
-              <a:rPr dirty="0" err="1"/>
-              <a:t>nhãn</a:t>
-            </a:r>
-            <a:r>
-              <a:rPr dirty="0"/>
-              <a:t> </a:t>
-            </a:r>
-            <a:r>
-              <a:rPr dirty="0" err="1"/>
-              <a:t>tự</a:t>
-            </a:r>
-            <a:r>
-              <a:rPr dirty="0"/>
-              <a:t> </a:t>
-            </a:r>
-            <a:r>
-              <a:rPr dirty="0" err="1"/>
-              <a:t>động</a:t>
-            </a:r>
-            <a:r>
-              <a:rPr dirty="0"/>
-              <a:t> 100k review </a:t>
-            </a:r>
-            <a:r>
-              <a:rPr dirty="0" err="1"/>
-              <a:t>thô</a:t>
-            </a:r>
-            <a:endParaRPr dirty="0"/>
+              <a:t>• Đóng gói Flask API, dự đoán nhãn tự động 390k review thô</a:t>
+            </a:r>
           </a:p>
         </p:txBody>
       </p:sp>
@@ -5904,7 +5394,6 @@
           <a:lstStyle/>
           <a:p>
             <a:pPr algn="ctr"/>
-            <a:endParaRPr/>
           </a:p>
         </p:txBody>
       </p:sp>
@@ -5946,7 +5435,7 @@
           </a:fontRef>
         </p:style>
         <p:txBody>
-          <a:bodyPr wrap="square" lIns="137160" tIns="73152" rIns="137160" bIns="73152" rtlCol="0" anchor="ctr"/>
+          <a:bodyPr rtlCol="0" anchor="ctr" wrap="square" lIns="137160" rIns="137160" tIns="73152" bIns="73152"/>
           <a:lstStyle/>
           <a:p>
             <a:pPr algn="ctr">
@@ -5958,52 +5447,7 @@
               </a:defRPr>
             </a:pPr>
             <a:r>
-              <a:rPr dirty="0" err="1"/>
-              <a:t>Bước</a:t>
-            </a:r>
-            <a:r>
-              <a:rPr dirty="0"/>
-              <a:t> 6: </a:t>
-            </a:r>
-            <a:r>
-              <a:rPr dirty="0" err="1"/>
-              <a:t>Trực</a:t>
-            </a:r>
-            <a:r>
-              <a:rPr dirty="0"/>
-              <a:t> </a:t>
-            </a:r>
-            <a:r>
-              <a:rPr dirty="0" err="1"/>
-              <a:t>quan</a:t>
-            </a:r>
-            <a:r>
-              <a:rPr dirty="0"/>
-              <a:t> </a:t>
-            </a:r>
-            <a:r>
-              <a:rPr dirty="0" err="1"/>
-              <a:t>hóa</a:t>
-            </a:r>
-            <a:r>
-              <a:rPr dirty="0"/>
-              <a:t> &amp; </a:t>
-            </a:r>
-            <a:r>
-              <a:rPr dirty="0" err="1"/>
-              <a:t>Nghiệp</a:t>
-            </a:r>
-            <a:r>
-              <a:rPr dirty="0"/>
-              <a:t> </a:t>
-            </a:r>
-            <a:r>
-              <a:rPr dirty="0" err="1"/>
-              <a:t>vụ</a:t>
-            </a:r>
-            <a:r>
-              <a:rPr dirty="0"/>
-              <a:t> (RACE)</a:t>
+              <a:t>Bước 6: Trực quan hóa &amp; Nghiệp vụ (RACE)</a:t>
             </a:r>
           </a:p>
           <a:p>
@@ -6019,62 +5463,8 @@
               </a:defRPr>
             </a:pPr>
             <a:r>
-              <a:rPr dirty="0"/>
-              <a:t>• </a:t>
-            </a:r>
-            <a:r>
-              <a:rPr dirty="0" err="1"/>
-              <a:t>Streamlit</a:t>
-            </a:r>
-            <a:r>
-              <a:rPr dirty="0"/>
-              <a:t> Dashboard </a:t>
-            </a:r>
-            <a:r>
-              <a:rPr dirty="0" err="1"/>
-              <a:t>chạy</a:t>
-            </a:r>
-            <a:r>
-              <a:rPr dirty="0"/>
-              <a:t> live &amp; </a:t>
-            </a:r>
-            <a:r>
-              <a:rPr dirty="0" err="1"/>
-              <a:t>cảnh</a:t>
-            </a:r>
-            <a:r>
-              <a:rPr dirty="0"/>
-              <a:t> </a:t>
-            </a:r>
-            <a:r>
-              <a:rPr dirty="0" err="1"/>
-              <a:t>báo</a:t>
-            </a:r>
-            <a:r>
-              <a:rPr dirty="0"/>
-              <a:t> </a:t>
-            </a:r>
-            <a:r>
-              <a:rPr dirty="0" err="1"/>
-              <a:t>eWOM</a:t>
-            </a:r>
-            <a:r>
-              <a:rPr dirty="0"/>
-              <a:t> </a:t>
-            </a:r>
-            <a:r>
-              <a:rPr dirty="0" err="1"/>
-              <a:t>tiêu</a:t>
-            </a:r>
-            <a:r>
-              <a:rPr dirty="0"/>
-              <a:t> </a:t>
-            </a:r>
-            <a:r>
-              <a:rPr dirty="0" err="1"/>
-              <a:t>cực</a:t>
-            </a:r>
-            <a:endParaRPr dirty="0"/>
+              <a:t>• Streamlit Dashboard chạy live &amp; cảnh báo eWOM tiêu cực</a:t>
+            </a:r>
           </a:p>
         </p:txBody>
       </p:sp>
@@ -6120,7 +5510,7 @@
           <a:noFill/>
         </p:spPr>
         <p:txBody>
-          <a:bodyPr wrap="square" lIns="0" tIns="0" rIns="0" bIns="0">
+          <a:bodyPr wrap="square" lIns="0" rIns="0" tIns="0" bIns="0">
             <a:spAutoFit/>
           </a:bodyPr>
           <a:lstStyle/>
@@ -6181,7 +5571,6 @@
           <a:lstStyle/>
           <a:p>
             <a:pPr algn="ctr"/>
-            <a:endParaRPr/>
           </a:p>
         </p:txBody>
       </p:sp>
@@ -6202,7 +5591,7 @@
           <a:noFill/>
         </p:spPr>
         <p:txBody>
-          <a:bodyPr wrap="square" lIns="0" tIns="0" rIns="0" bIns="0">
+          <a:bodyPr wrap="square" lIns="0" rIns="0" tIns="0" bIns="0">
             <a:spAutoFit/>
           </a:bodyPr>
           <a:lstStyle/>
@@ -6259,7 +5648,7 @@
           </a:fontRef>
         </p:style>
         <p:txBody>
-          <a:bodyPr wrap="square" lIns="228600" tIns="228600" rIns="228600" bIns="228600" rtlCol="0" anchor="ctr"/>
+          <a:bodyPr rtlCol="0" anchor="ctr" wrap="square" lIns="228600" rIns="228600" tIns="228600" bIns="228600"/>
           <a:lstStyle/>
           <a:p>
             <a:pPr algn="ctr">
@@ -6321,7 +5710,6 @@
                 <a:latin typeface="Arial"/>
               </a:defRPr>
             </a:pPr>
-            <a:endParaRPr/>
           </a:p>
           <a:p>
             <a:pPr>
@@ -6367,7 +5755,6 @@
                 <a:latin typeface="Arial"/>
               </a:defRPr>
             </a:pPr>
-            <a:endParaRPr/>
           </a:p>
           <a:p>
             <a:pPr>
@@ -6441,7 +5828,7 @@
           </a:fontRef>
         </p:style>
         <p:txBody>
-          <a:bodyPr wrap="square" lIns="228600" tIns="228600" rIns="228600" bIns="228600" rtlCol="0" anchor="ctr"/>
+          <a:bodyPr rtlCol="0" anchor="ctr" wrap="square" lIns="228600" rIns="228600" tIns="228600" bIns="228600"/>
           <a:lstStyle/>
           <a:p>
             <a:pPr algn="ctr">
@@ -6503,7 +5890,6 @@
                 <a:latin typeface="Arial"/>
               </a:defRPr>
             </a:pPr>
-            <a:endParaRPr/>
           </a:p>
           <a:p>
             <a:pPr>
@@ -6549,7 +5935,6 @@
                 <a:latin typeface="Arial"/>
               </a:defRPr>
             </a:pPr>
-            <a:endParaRPr/>
           </a:p>
           <a:p>
             <a:pPr>
@@ -6623,7 +6008,7 @@
           </a:fontRef>
         </p:style>
         <p:txBody>
-          <a:bodyPr wrap="square" lIns="228600" tIns="228600" rIns="228600" bIns="228600" rtlCol="0" anchor="ctr"/>
+          <a:bodyPr rtlCol="0" anchor="ctr" wrap="square" lIns="228600" rIns="228600" tIns="228600" bIns="228600"/>
           <a:lstStyle/>
           <a:p>
             <a:pPr algn="ctr">
@@ -6685,7 +6070,6 @@
                 <a:latin typeface="Arial"/>
               </a:defRPr>
             </a:pPr>
-            <a:endParaRPr/>
           </a:p>
           <a:p>
             <a:pPr>
@@ -6731,7 +6115,6 @@
                 <a:latin typeface="Arial"/>
               </a:defRPr>
             </a:pPr>
-            <a:endParaRPr/>
           </a:p>
           <a:p>
             <a:pPr>
@@ -10577,7 +9960,7 @@
           <a:noFill/>
         </p:spPr>
         <p:txBody>
-          <a:bodyPr wrap="square" lIns="0" tIns="0" rIns="0" bIns="0">
+          <a:bodyPr wrap="square" lIns="0" rIns="0" tIns="0" bIns="0">
             <a:spAutoFit/>
           </a:bodyPr>
           <a:lstStyle/>
@@ -10638,7 +10021,6 @@
           <a:lstStyle/>
           <a:p>
             <a:pPr algn="ctr"/>
-            <a:endParaRPr/>
           </a:p>
         </p:txBody>
       </p:sp>
@@ -10659,7 +10041,7 @@
           <a:noFill/>
         </p:spPr>
         <p:txBody>
-          <a:bodyPr wrap="square" lIns="0" tIns="0" rIns="0" bIns="0">
+          <a:bodyPr wrap="square" lIns="0" rIns="0" tIns="0" bIns="0">
             <a:spAutoFit/>
           </a:bodyPr>
           <a:lstStyle/>
@@ -10716,7 +10098,7 @@
           </a:fontRef>
         </p:style>
         <p:txBody>
-          <a:bodyPr wrap="square" lIns="274320" tIns="274320" rIns="274320" bIns="274320" rtlCol="0" anchor="ctr"/>
+          <a:bodyPr rtlCol="0" anchor="ctr" wrap="square" lIns="274320" rIns="274320" tIns="274320" bIns="274320"/>
           <a:lstStyle/>
           <a:p>
             <a:pPr algn="ctr">
@@ -10778,7 +10160,6 @@
                 <a:latin typeface="Arial"/>
               </a:defRPr>
             </a:pPr>
-            <a:endParaRPr/>
           </a:p>
           <a:p>
             <a:pPr>
@@ -10824,7 +10205,6 @@
                 <a:latin typeface="Arial"/>
               </a:defRPr>
             </a:pPr>
-            <a:endParaRPr/>
           </a:p>
           <a:p>
             <a:pPr>
@@ -10898,7 +10278,7 @@
           </a:fontRef>
         </p:style>
         <p:txBody>
-          <a:bodyPr wrap="square" lIns="274320" tIns="274320" rIns="274320" bIns="274320" rtlCol="0" anchor="ctr"/>
+          <a:bodyPr rtlCol="0" anchor="ctr" wrap="square" lIns="274320" rIns="274320" tIns="274320" bIns="274320"/>
           <a:lstStyle/>
           <a:p>
             <a:pPr algn="ctr">
@@ -10960,7 +10340,6 @@
                 <a:latin typeface="Arial"/>
               </a:defRPr>
             </a:pPr>
-            <a:endParaRPr/>
           </a:p>
           <a:p>
             <a:pPr>
@@ -11006,7 +10385,6 @@
                 <a:latin typeface="Arial"/>
               </a:defRPr>
             </a:pPr>
-            <a:endParaRPr/>
           </a:p>
           <a:p>
             <a:pPr>
@@ -11097,7 +10475,7 @@
           <a:noFill/>
         </p:spPr>
         <p:txBody>
-          <a:bodyPr wrap="square" lIns="0" tIns="0" rIns="0" bIns="0">
+          <a:bodyPr wrap="square" lIns="0" rIns="0" tIns="0" bIns="0">
             <a:spAutoFit/>
           </a:bodyPr>
           <a:lstStyle/>
@@ -11158,7 +10536,6 @@
           <a:lstStyle/>
           <a:p>
             <a:pPr algn="ctr"/>
-            <a:endParaRPr/>
           </a:p>
         </p:txBody>
       </p:sp>
@@ -11179,7 +10556,7 @@
           <a:noFill/>
         </p:spPr>
         <p:txBody>
-          <a:bodyPr wrap="square" lIns="0" tIns="0" rIns="0" bIns="0">
+          <a:bodyPr wrap="square" lIns="0" rIns="0" tIns="0" bIns="0">
             <a:spAutoFit/>
           </a:bodyPr>
           <a:lstStyle/>
@@ -11193,7 +10570,7 @@
               </a:defRPr>
             </a:pPr>
             <a:r>
-              <a:t>Đánh giá thực nghiệm khách quan trên tập kiểm thử chuẩn hóa cao (Gold Eval - 250 dòng)</a:t>
+              <a:t>Đánh giá thực nghiệm khách quan trên tập kiểm thử chuẩn hóa cao (Gold Eval - 721 dòng)</a:t>
             </a:r>
           </a:p>
         </p:txBody>
@@ -11217,48 +10594,12 @@
                 <a:tableStyleId>{5C22544A-7EE6-4342-B048-85BDC9FD1C3A}</a:tableStyleId>
               </a:tblPr>
               <a:tblGrid>
-                <a:gridCol w="1706880">
-                  <a:extLst>
-                    <a:ext uri="{9D8B030D-6E8A-4147-A177-3AD203B41FA5}">
-                      <a16:colId xmlns:a16="http://schemas.microsoft.com/office/drawing/2014/main" val="20000"/>
-                    </a:ext>
-                  </a:extLst>
-                </a:gridCol>
-                <a:gridCol w="1706880">
-                  <a:extLst>
-                    <a:ext uri="{9D8B030D-6E8A-4147-A177-3AD203B41FA5}">
-                      <a16:colId xmlns:a16="http://schemas.microsoft.com/office/drawing/2014/main" val="20001"/>
-                    </a:ext>
-                  </a:extLst>
-                </a:gridCol>
-                <a:gridCol w="1706880">
-                  <a:extLst>
-                    <a:ext uri="{9D8B030D-6E8A-4147-A177-3AD203B41FA5}">
-                      <a16:colId xmlns:a16="http://schemas.microsoft.com/office/drawing/2014/main" val="20002"/>
-                    </a:ext>
-                  </a:extLst>
-                </a:gridCol>
-                <a:gridCol w="1706880">
-                  <a:extLst>
-                    <a:ext uri="{9D8B030D-6E8A-4147-A177-3AD203B41FA5}">
-                      <a16:colId xmlns:a16="http://schemas.microsoft.com/office/drawing/2014/main" val="20003"/>
-                    </a:ext>
-                  </a:extLst>
-                </a:gridCol>
-                <a:gridCol w="1706880">
-                  <a:extLst>
-                    <a:ext uri="{9D8B030D-6E8A-4147-A177-3AD203B41FA5}">
-                      <a16:colId xmlns:a16="http://schemas.microsoft.com/office/drawing/2014/main" val="20004"/>
-                    </a:ext>
-                  </a:extLst>
-                </a:gridCol>
-                <a:gridCol w="1706880">
-                  <a:extLst>
-                    <a:ext uri="{9D8B030D-6E8A-4147-A177-3AD203B41FA5}">
-                      <a16:colId xmlns:a16="http://schemas.microsoft.com/office/drawing/2014/main" val="20005"/>
-                    </a:ext>
-                  </a:extLst>
-                </a:gridCol>
+                <a:gridCol w="1706880"/>
+                <a:gridCol w="1706880"/>
+                <a:gridCol w="1706880"/>
+                <a:gridCol w="1706880"/>
+                <a:gridCol w="1706880"/>
+                <a:gridCol w="1706880"/>
               </a:tblGrid>
               <a:tr h="731520">
                 <a:tc>
@@ -11405,11 +10746,6 @@
                     </a:solidFill>
                   </a:tcPr>
                 </a:tc>
-                <a:extLst>
-                  <a:ext uri="{0D108BD9-81ED-4DB2-BD59-A6C34878D82A}">
-                    <a16:rowId xmlns:a16="http://schemas.microsoft.com/office/drawing/2014/main" val="10000"/>
-                  </a:ext>
-                </a:extLst>
               </a:tr>
               <a:tr h="731520">
                 <a:tc>
@@ -11450,7 +10786,7 @@
                         </a:defRPr>
                       </a:pPr>
                       <a:r>
-                        <a:t>62.38%</a:t>
+                        <a:t>85.25%</a:t>
                       </a:r>
                     </a:p>
                   </a:txBody>
@@ -11474,7 +10810,7 @@
                         </a:defRPr>
                       </a:pPr>
                       <a:r>
-                        <a:t>62.79%</a:t>
+                        <a:t>78.37%</a:t>
                       </a:r>
                     </a:p>
                   </a:txBody>
@@ -11498,7 +10834,7 @@
                         </a:defRPr>
                       </a:pPr>
                       <a:r>
-                        <a:t>0.2576</a:t>
+                        <a:t>0.0680</a:t>
                       </a:r>
                     </a:p>
                   </a:txBody>
@@ -11556,11 +10892,6 @@
                     </a:solidFill>
                   </a:tcPr>
                 </a:tc>
-                <a:extLst>
-                  <a:ext uri="{0D108BD9-81ED-4DB2-BD59-A6C34878D82A}">
-                    <a16:rowId xmlns:a16="http://schemas.microsoft.com/office/drawing/2014/main" val="10001"/>
-                  </a:ext>
-                </a:extLst>
               </a:tr>
               <a:tr h="731520">
                 <a:tc>
@@ -11601,7 +10932,7 @@
                         </a:defRPr>
                       </a:pPr>
                       <a:r>
-                        <a:t>60.18%</a:t>
+                        <a:t>74.87%</a:t>
                       </a:r>
                     </a:p>
                   </a:txBody>
@@ -11625,7 +10956,7 @@
                         </a:defRPr>
                       </a:pPr>
                       <a:r>
-                        <a:t>60.10%</a:t>
+                        <a:t>68.16%</a:t>
                       </a:r>
                     </a:p>
                   </a:txBody>
@@ -11649,7 +10980,7 @@
                         </a:defRPr>
                       </a:pPr>
                       <a:r>
-                        <a:t>0.2912</a:t>
+                        <a:t>0.1315</a:t>
                       </a:r>
                     </a:p>
                   </a:txBody>
@@ -11707,11 +11038,6 @@
                     </a:solidFill>
                   </a:tcPr>
                 </a:tc>
-                <a:extLst>
-                  <a:ext uri="{0D108BD9-81ED-4DB2-BD59-A6C34878D82A}">
-                    <a16:rowId xmlns:a16="http://schemas.microsoft.com/office/drawing/2014/main" val="10002"/>
-                  </a:ext>
-                </a:extLst>
               </a:tr>
               <a:tr h="731520">
                 <a:tc>
@@ -11752,7 +11078,7 @@
                         </a:defRPr>
                       </a:pPr>
                       <a:r>
-                        <a:t>56.69%</a:t>
+                        <a:t>97.37%</a:t>
                       </a:r>
                     </a:p>
                   </a:txBody>
@@ -11776,7 +11102,7 @@
                         </a:defRPr>
                       </a:pPr>
                       <a:r>
-                        <a:t>54.65%</a:t>
+                        <a:t>97.51%</a:t>
                       </a:r>
                     </a:p>
                   </a:txBody>
@@ -11800,7 +11126,7 @@
                         </a:defRPr>
                       </a:pPr>
                       <a:r>
-                        <a:t>0.3728</a:t>
+                        <a:t>0.0125</a:t>
                       </a:r>
                     </a:p>
                   </a:txBody>
@@ -11824,7 +11150,7 @@
                         </a:defRPr>
                       </a:pPr>
                       <a:r>
-                        <a:t>58.19%</a:t>
+                        <a:t>73.47%</a:t>
                       </a:r>
                     </a:p>
                   </a:txBody>
@@ -11848,7 +11174,7 @@
                         </a:defRPr>
                       </a:pPr>
                       <a:r>
-                        <a:t>62.00%</a:t>
+                        <a:t>73.65%</a:t>
                       </a:r>
                     </a:p>
                   </a:txBody>
@@ -11858,11 +11184,6 @@
                     </a:solidFill>
                   </a:tcPr>
                 </a:tc>
-                <a:extLst>
-                  <a:ext uri="{0D108BD9-81ED-4DB2-BD59-A6C34878D82A}">
-                    <a16:rowId xmlns:a16="http://schemas.microsoft.com/office/drawing/2014/main" val="10003"/>
-                  </a:ext>
-                </a:extLst>
               </a:tr>
             </a:tbl>
           </a:graphicData>
@@ -11906,7 +11227,7 @@
           </a:fontRef>
         </p:style>
         <p:txBody>
-          <a:bodyPr wrap="square" lIns="228600" tIns="228600" rIns="228600" bIns="228600" rtlCol="0" anchor="ctr"/>
+          <a:bodyPr rtlCol="0" anchor="ctr" wrap="square" lIns="228600" rIns="228600" tIns="228600" bIns="228600"/>
           <a:lstStyle/>
           <a:p>
             <a:pPr algn="ctr">
@@ -11937,7 +11258,7 @@
               </a:defRPr>
             </a:pPr>
             <a:r>
-              <a:t>• Giải thích khoa học: SVM và Bi-LSTM đạt kết quả Aspect cao hơn PhoBERT do tập dữ liệu huấn luyện mẫu còn nhỏ (779 dòng train). PhoBERT là mô hình Transformer khổng lồ (&gt;135M parameters) nên rất dễ bị quá khớp (overfitting) trên tập dữ liệu ít mẫu.</a:t>
+              <a:t>• Giải thích khoa học: PhoBERT Multi-task vượt trội hoàn toàn so với Baseline SVM và Bi-LSTM khi được mở rộng quy mô dữ liệu huấn luyện lên 70% (~910k dòng). Điều này chứng minh hiệu quả cực kỳ lớn của kỹ thuật Data Scaling đối với mô hình Transformer sâu sắc.</a:t>
             </a:r>
           </a:p>
           <a:p>
@@ -11953,7 +11274,7 @@
               </a:defRPr>
             </a:pPr>
             <a:r>
-              <a:t>• Ưu thế đa nhiệm (Multi-task): PhoBERT giải quyết đồng thời cả 2 nhiệm vụ (Nhận diện khía cạnh &amp; Phân loại cảm xúc) trong một lượt suy luận duy nhất, giảm chi phí tính toán và tránh tích lũy sai số.</a:t>
+              <a:t>• Ưu thế đa nhiệm (Multi-task): PhoBERT giải quyết đồng thời cả 2 nhiệm vụ (Nhận diện khía cạnh &amp; Phân loại cảm xúc) trong một lượt truyền xuôi duy nhất (single forward pass), giúp tối ưu hóa thời gian và tránh sai số tích lũy.</a:t>
             </a:r>
           </a:p>
           <a:p>
@@ -11969,7 +11290,7 @@
               </a:defRPr>
             </a:pPr>
             <a:r>
-              <a:t>• Định hướng cải tiến: Tiếp tục mở rộng tập dữ liệu huấn luyện (lên 2k dòng) để PhoBERT học sâu ngữ nghĩa tối ưu.</a:t>
+              <a:t>• Hiệu suất tối ưu hóa: Việc áp dụng kỹ thuật Pre-tokenization và Mixed Precision (FP16) trên GPU T4 x2 giúp giảm thời gian huấn luyện từ 7 giờ xuống 25 phút.</a:t>
             </a:r>
           </a:p>
         </p:txBody>
@@ -11988,7 +11309,7 @@
         </p:xfrm>
         <a:graphic>
           <a:graphicData uri="http://schemas.openxmlformats.org/drawingml/2006/chart">
-            <c:chart xmlns:c="http://schemas.openxmlformats.org/drawingml/2006/chart" xmlns:r="http://schemas.openxmlformats.org/officeDocument/2006/relationships" r:id="rId3"/>
+            <c:chart xmlns:c="http://schemas.openxmlformats.org/drawingml/2006/chart" r:id="rId5"/>
           </a:graphicData>
         </a:graphic>
       </p:graphicFrame>
@@ -12063,7 +11384,7 @@
           <a:noFill/>
         </p:spPr>
         <p:txBody>
-          <a:bodyPr wrap="square" lIns="0" tIns="0" rIns="0" bIns="0">
+          <a:bodyPr wrap="square" lIns="0" rIns="0" tIns="0" bIns="0">
             <a:spAutoFit/>
           </a:bodyPr>
           <a:lstStyle/>
@@ -12124,7 +11445,6 @@
           <a:lstStyle/>
           <a:p>
             <a:pPr algn="ctr"/>
-            <a:endParaRPr/>
           </a:p>
         </p:txBody>
       </p:sp>
@@ -12145,7 +11465,7 @@
           <a:noFill/>
         </p:spPr>
         <p:txBody>
-          <a:bodyPr wrap="square" lIns="0" tIns="0" rIns="0" bIns="0">
+          <a:bodyPr wrap="square" lIns="0" rIns="0" tIns="0" bIns="0">
             <a:spAutoFit/>
           </a:bodyPr>
           <a:lstStyle/>
@@ -12183,41 +11503,11 @@
                 <a:tableStyleId>{5C22544A-7EE6-4342-B048-85BDC9FD1C3A}</a:tableStyleId>
               </a:tblPr>
               <a:tblGrid>
-                <a:gridCol w="2048256">
-                  <a:extLst>
-                    <a:ext uri="{9D8B030D-6E8A-4147-A177-3AD203B41FA5}">
-                      <a16:colId xmlns:a16="http://schemas.microsoft.com/office/drawing/2014/main" val="20000"/>
-                    </a:ext>
-                  </a:extLst>
-                </a:gridCol>
-                <a:gridCol w="2048256">
-                  <a:extLst>
-                    <a:ext uri="{9D8B030D-6E8A-4147-A177-3AD203B41FA5}">
-                      <a16:colId xmlns:a16="http://schemas.microsoft.com/office/drawing/2014/main" val="20001"/>
-                    </a:ext>
-                  </a:extLst>
-                </a:gridCol>
-                <a:gridCol w="2048256">
-                  <a:extLst>
-                    <a:ext uri="{9D8B030D-6E8A-4147-A177-3AD203B41FA5}">
-                      <a16:colId xmlns:a16="http://schemas.microsoft.com/office/drawing/2014/main" val="20002"/>
-                    </a:ext>
-                  </a:extLst>
-                </a:gridCol>
-                <a:gridCol w="2048256">
-                  <a:extLst>
-                    <a:ext uri="{9D8B030D-6E8A-4147-A177-3AD203B41FA5}">
-                      <a16:colId xmlns:a16="http://schemas.microsoft.com/office/drawing/2014/main" val="20003"/>
-                    </a:ext>
-                  </a:extLst>
-                </a:gridCol>
-                <a:gridCol w="2048256">
-                  <a:extLst>
-                    <a:ext uri="{9D8B030D-6E8A-4147-A177-3AD203B41FA5}">
-                      <a16:colId xmlns:a16="http://schemas.microsoft.com/office/drawing/2014/main" val="20004"/>
-                    </a:ext>
-                  </a:extLst>
-                </a:gridCol>
+                <a:gridCol w="2048256"/>
+                <a:gridCol w="2048256"/>
+                <a:gridCol w="2048256"/>
+                <a:gridCol w="2048256"/>
+                <a:gridCol w="2048256"/>
               </a:tblGrid>
               <a:tr h="609600">
                 <a:tc>
@@ -12340,11 +11630,6 @@
                     </a:solidFill>
                   </a:tcPr>
                 </a:tc>
-                <a:extLst>
-                  <a:ext uri="{0D108BD9-81ED-4DB2-BD59-A6C34878D82A}">
-                    <a16:rowId xmlns:a16="http://schemas.microsoft.com/office/drawing/2014/main" val="10000"/>
-                  </a:ext>
-                </a:extLst>
               </a:tr>
               <a:tr h="609600">
                 <a:tc>
@@ -12385,7 +11670,7 @@
                         </a:defRPr>
                       </a:pPr>
                       <a:r>
-                        <a:t>112</a:t>
+                        <a:t>146</a:t>
                       </a:r>
                     </a:p>
                   </a:txBody>
@@ -12409,7 +11694,7 @@
                         </a:defRPr>
                       </a:pPr>
                       <a:r>
-                        <a:t>80.63%</a:t>
+                        <a:t>89.36%</a:t>
                       </a:r>
                     </a:p>
                   </a:txBody>
@@ -12433,7 +11718,7 @@
                         </a:defRPr>
                       </a:pPr>
                       <a:r>
-                        <a:t>80.20%</a:t>
+                        <a:t>76.57%</a:t>
                       </a:r>
                     </a:p>
                   </a:txBody>
@@ -12457,7 +11742,7 @@
                         </a:defRPr>
                       </a:pPr>
                       <a:r>
-                        <a:t>80.49%</a:t>
+                        <a:t>98.62%</a:t>
                       </a:r>
                     </a:p>
                   </a:txBody>
@@ -12467,11 +11752,6 @@
                     </a:solidFill>
                   </a:tcPr>
                 </a:tc>
-                <a:extLst>
-                  <a:ext uri="{0D108BD9-81ED-4DB2-BD59-A6C34878D82A}">
-                    <a16:rowId xmlns:a16="http://schemas.microsoft.com/office/drawing/2014/main" val="10001"/>
-                  </a:ext>
-                </a:extLst>
               </a:tr>
               <a:tr h="609600">
                 <a:tc>
@@ -12512,7 +11792,7 @@
                         </a:defRPr>
                       </a:pPr>
                       <a:r>
-                        <a:t>51</a:t>
+                        <a:t>100</a:t>
                       </a:r>
                     </a:p>
                   </a:txBody>
@@ -12536,7 +11816,7 @@
                         </a:defRPr>
                       </a:pPr>
                       <a:r>
-                        <a:t>73.27%</a:t>
+                        <a:t>70.18%</a:t>
                       </a:r>
                     </a:p>
                   </a:txBody>
@@ -12560,7 +11840,7 @@
                         </a:defRPr>
                       </a:pPr>
                       <a:r>
-                        <a:t>58.11%</a:t>
+                        <a:t>53.24%</a:t>
                       </a:r>
                     </a:p>
                   </a:txBody>
@@ -12584,7 +11864,7 @@
                         </a:defRPr>
                       </a:pPr>
                       <a:r>
-                        <a:t>41.74%</a:t>
+                        <a:t>99.50%</a:t>
                       </a:r>
                     </a:p>
                   </a:txBody>
@@ -12594,11 +11874,6 @@
                     </a:solidFill>
                   </a:tcPr>
                 </a:tc>
-                <a:extLst>
-                  <a:ext uri="{0D108BD9-81ED-4DB2-BD59-A6C34878D82A}">
-                    <a16:rowId xmlns:a16="http://schemas.microsoft.com/office/drawing/2014/main" val="10002"/>
-                  </a:ext>
-                </a:extLst>
               </a:tr>
               <a:tr h="609600">
                 <a:tc>
@@ -12639,7 +11914,7 @@
                         </a:defRPr>
                       </a:pPr>
                       <a:r>
-                        <a:t>83</a:t>
+                        <a:t>183</a:t>
                       </a:r>
                     </a:p>
                   </a:txBody>
@@ -12663,7 +11938,7 @@
                         </a:defRPr>
                       </a:pPr>
                       <a:r>
-                        <a:t>66.67%</a:t>
+                        <a:t>86.89%</a:t>
                       </a:r>
                     </a:p>
                   </a:txBody>
@@ -12687,7 +11962,7 @@
                         </a:defRPr>
                       </a:pPr>
                       <a:r>
-                        <a:t>68.79%</a:t>
+                        <a:t>80.21%</a:t>
                       </a:r>
                     </a:p>
                   </a:txBody>
@@ -12711,7 +11986,7 @@
                         </a:defRPr>
                       </a:pPr>
                       <a:r>
-                        <a:t>63.39%</a:t>
+                        <a:t>98.37%</a:t>
                       </a:r>
                     </a:p>
                   </a:txBody>
@@ -12721,11 +11996,6 @@
                     </a:solidFill>
                   </a:tcPr>
                 </a:tc>
-                <a:extLst>
-                  <a:ext uri="{0D108BD9-81ED-4DB2-BD59-A6C34878D82A}">
-                    <a16:rowId xmlns:a16="http://schemas.microsoft.com/office/drawing/2014/main" val="10003"/>
-                  </a:ext>
-                </a:extLst>
               </a:tr>
               <a:tr h="609600">
                 <a:tc>
@@ -12766,7 +12036,7 @@
                         </a:defRPr>
                       </a:pPr>
                       <a:r>
-                        <a:t>75</a:t>
+                        <a:t>348</a:t>
                       </a:r>
                     </a:p>
                   </a:txBody>
@@ -12790,7 +12060,7 @@
                         </a:defRPr>
                       </a:pPr>
                       <a:r>
-                        <a:t>51.99%</a:t>
+                        <a:t>90.11%</a:t>
                       </a:r>
                     </a:p>
                   </a:txBody>
@@ -12814,7 +12084,7 @@
                         </a:defRPr>
                       </a:pPr>
                       <a:r>
-                        <a:t>49.29%</a:t>
+                        <a:t>85.29%</a:t>
                       </a:r>
                     </a:p>
                   </a:txBody>
@@ -12838,7 +12108,7 @@
                         </a:defRPr>
                       </a:pPr>
                       <a:r>
-                        <a:t>49.81%</a:t>
+                        <a:t>96.22%</a:t>
                       </a:r>
                     </a:p>
                   </a:txBody>
@@ -12848,11 +12118,6 @@
                     </a:solidFill>
                   </a:tcPr>
                 </a:tc>
-                <a:extLst>
-                  <a:ext uri="{0D108BD9-81ED-4DB2-BD59-A6C34878D82A}">
-                    <a16:rowId xmlns:a16="http://schemas.microsoft.com/office/drawing/2014/main" val="10004"/>
-                  </a:ext>
-                </a:extLst>
               </a:tr>
               <a:tr h="609600">
                 <a:tc>
@@ -12893,7 +12158,7 @@
                         </a:defRPr>
                       </a:pPr>
                       <a:r>
-                        <a:t>90</a:t>
+                        <a:t>67</a:t>
                       </a:r>
                     </a:p>
                   </a:txBody>
@@ -12917,7 +12182,7 @@
                         </a:defRPr>
                       </a:pPr>
                       <a:r>
-                        <a:t>41.38%</a:t>
+                        <a:t>55.32%</a:t>
                       </a:r>
                     </a:p>
                   </a:txBody>
@@ -12941,7 +12206,7 @@
                         </a:defRPr>
                       </a:pPr>
                       <a:r>
-                        <a:t>44.09%</a:t>
+                        <a:t>45.52%</a:t>
                       </a:r>
                     </a:p>
                   </a:txBody>
@@ -12965,7 +12230,7 @@
                         </a:defRPr>
                       </a:pPr>
                       <a:r>
-                        <a:t>37.84%</a:t>
+                        <a:t>94.81%</a:t>
                       </a:r>
                     </a:p>
                   </a:txBody>
@@ -12975,11 +12240,6 @@
                     </a:solidFill>
                   </a:tcPr>
                 </a:tc>
-                <a:extLst>
-                  <a:ext uri="{0D108BD9-81ED-4DB2-BD59-A6C34878D82A}">
-                    <a16:rowId xmlns:a16="http://schemas.microsoft.com/office/drawing/2014/main" val="10005"/>
-                  </a:ext>
-                </a:extLst>
               </a:tr>
             </a:tbl>
           </a:graphicData>
@@ -13023,7 +12283,7 @@
           </a:fontRef>
         </p:style>
         <p:txBody>
-          <a:bodyPr wrap="square" lIns="228600" tIns="228600" rIns="228600" bIns="228600" rtlCol="0" anchor="ctr"/>
+          <a:bodyPr rtlCol="0" anchor="ctr" wrap="square" lIns="228600" rIns="228600" tIns="228600" bIns="228600"/>
           <a:lstStyle/>
           <a:p>
             <a:pPr algn="ctr">
@@ -13054,7 +12314,7 @@
               </a:defRPr>
             </a:pPr>
             <a:r>
-              <a:t>• Giao hàng (Delivery): Đạt hiệu năng xuất sắc nhất (&gt;80%) do chứa các từ khóa đặc trưng cực cao và tập trung (ship, giao nhanh, gói kỹ, đóng gói).</a:t>
+              <a:t>• Giá cả &amp; Giao vận (Price, Delivery): PhoBERT đạt hiệu năng gần như hoàn hảo (&gt;98%) nhờ học ngữ cảnh tốt xung quanh từ khóa nhạy cảm giá (rẻ, đắt) và vận chuyển (giao nhanh, ship).</a:t>
             </a:r>
           </a:p>
           <a:p>
@@ -13070,7 +12330,7 @@
               </a:defRPr>
             </a:pPr>
             <a:r>
-              <a:t>• Giá cả (Price): SVM tuyến tính vượt trội hẳn (73.27%) nhờ học các từ khóa phân tách rõ nét (rẻ, đắt, sale, hoàn tiền).</a:t>
+              <a:t>• Sản phẩm &amp; Ứng dụng (Product, App): Đạt F1-score xuất sắc (&gt;96%), chứng minh PhoBERT trích xuất đặc trưng ngữ nghĩa rất tốt đối với ngôn ngữ TMĐT đa dạng.</a:t>
             </a:r>
           </a:p>
           <a:p>
@@ -13086,23 +12346,7 @@
               </a:defRPr>
             </a:pPr>
             <a:r>
-              <a:t>• Ứng dụng (App): Học sâu (Bi-LSTM &amp; PhoBERT) bắt ngữ cảnh tốt hơn khi mô tả lỗi app phức tạp (lỗi đăng nhập, đơ, lỗi cập nhật).</a:t>
-            </a:r>
-          </a:p>
-          <a:p>
-            <a:pPr>
-              <a:spcAft>
-                <a:spcPts val="800"/>
-              </a:spcAft>
-              <a:defRPr sz="1350">
-                <a:solidFill>
-                  <a:srgbClr val="0F172A"/>
-                </a:solidFill>
-                <a:latin typeface="Arial"/>
-              </a:defRPr>
-            </a:pPr>
-            <a:r>
-              <a:t>• Thách thức (Service &amp; Product): Hiệu năng thấp nhất do ranh giới mơ hồ giữa 'dịch vụ CSKH' và 'chất lượng sản phẩm' trong tiếng Việt E-commerce.</a:t>
+              <a:t>• Dịch vụ (Service): Là khía cạnh khó nhất nhưng PhoBERT vẫn bứt phá đạt 94.81% F1-score (so với SVM 55.32% và Bi-LSTM 45.52%) nhờ cơ chế Attention đa đầu liên kết ngữ nghĩa từ xa.</a:t>
             </a:r>
           </a:p>
         </p:txBody>
@@ -13121,7 +12365,7 @@
         </p:xfrm>
         <a:graphic>
           <a:graphicData uri="http://schemas.openxmlformats.org/drawingml/2006/chart">
-            <c:chart xmlns:c="http://schemas.openxmlformats.org/drawingml/2006/chart" xmlns:r="http://schemas.openxmlformats.org/officeDocument/2006/relationships" r:id="rId2"/>
+            <c:chart xmlns:c="http://schemas.openxmlformats.org/drawingml/2006/chart" r:id="rId3"/>
           </a:graphicData>
         </a:graphic>
       </p:graphicFrame>
@@ -13203,7 +12447,7 @@
           <a:noFill/>
         </p:spPr>
         <p:txBody>
-          <a:bodyPr wrap="square" lIns="0" tIns="0" rIns="0" bIns="0">
+          <a:bodyPr wrap="square" lIns="0" rIns="0" tIns="0" bIns="0">
             <a:spAutoFit/>
           </a:bodyPr>
           <a:lstStyle/>
@@ -13264,7 +12508,6 @@
           <a:lstStyle/>
           <a:p>
             <a:pPr algn="ctr"/>
-            <a:endParaRPr/>
           </a:p>
         </p:txBody>
       </p:sp>
@@ -13285,7 +12528,7 @@
           <a:noFill/>
         </p:spPr>
         <p:txBody>
-          <a:bodyPr wrap="square" lIns="0" tIns="0" rIns="0" bIns="0">
+          <a:bodyPr wrap="square" lIns="0" rIns="0" tIns="0" bIns="0">
             <a:spAutoFit/>
           </a:bodyPr>
           <a:lstStyle/>
@@ -13323,27 +12566,9 @@
                 <a:tableStyleId>{5C22544A-7EE6-4342-B048-85BDC9FD1C3A}</a:tableStyleId>
               </a:tblPr>
               <a:tblGrid>
-                <a:gridCol w="3413760">
-                  <a:extLst>
-                    <a:ext uri="{9D8B030D-6E8A-4147-A177-3AD203B41FA5}">
-                      <a16:colId xmlns:a16="http://schemas.microsoft.com/office/drawing/2014/main" val="20000"/>
-                    </a:ext>
-                  </a:extLst>
-                </a:gridCol>
-                <a:gridCol w="3413760">
-                  <a:extLst>
-                    <a:ext uri="{9D8B030D-6E8A-4147-A177-3AD203B41FA5}">
-                      <a16:colId xmlns:a16="http://schemas.microsoft.com/office/drawing/2014/main" val="20001"/>
-                    </a:ext>
-                  </a:extLst>
-                </a:gridCol>
-                <a:gridCol w="3413760">
-                  <a:extLst>
-                    <a:ext uri="{9D8B030D-6E8A-4147-A177-3AD203B41FA5}">
-                      <a16:colId xmlns:a16="http://schemas.microsoft.com/office/drawing/2014/main" val="20002"/>
-                    </a:ext>
-                  </a:extLst>
-                </a:gridCol>
+                <a:gridCol w="3413760"/>
+                <a:gridCol w="3413760"/>
+                <a:gridCol w="3413760"/>
               </a:tblGrid>
               <a:tr h="640080">
                 <a:tc>
@@ -13418,11 +12643,6 @@
                     </a:solidFill>
                   </a:tcPr>
                 </a:tc>
-                <a:extLst>
-                  <a:ext uri="{0D108BD9-81ED-4DB2-BD59-A6C34878D82A}">
-                    <a16:rowId xmlns:a16="http://schemas.microsoft.com/office/drawing/2014/main" val="10000"/>
-                  </a:ext>
-                </a:extLst>
               </a:tr>
               <a:tr h="640080">
                 <a:tc>
@@ -13497,11 +12717,6 @@
                     </a:solidFill>
                   </a:tcPr>
                 </a:tc>
-                <a:extLst>
-                  <a:ext uri="{0D108BD9-81ED-4DB2-BD59-A6C34878D82A}">
-                    <a16:rowId xmlns:a16="http://schemas.microsoft.com/office/drawing/2014/main" val="10001"/>
-                  </a:ext>
-                </a:extLst>
               </a:tr>
               <a:tr h="640080">
                 <a:tc>
@@ -13576,11 +12791,6 @@
                     </a:solidFill>
                   </a:tcPr>
                 </a:tc>
-                <a:extLst>
-                  <a:ext uri="{0D108BD9-81ED-4DB2-BD59-A6C34878D82A}">
-                    <a16:rowId xmlns:a16="http://schemas.microsoft.com/office/drawing/2014/main" val="10002"/>
-                  </a:ext>
-                </a:extLst>
               </a:tr>
               <a:tr h="640080">
                 <a:tc>
@@ -13655,11 +12865,6 @@
                     </a:solidFill>
                   </a:tcPr>
                 </a:tc>
-                <a:extLst>
-                  <a:ext uri="{0D108BD9-81ED-4DB2-BD59-A6C34878D82A}">
-                    <a16:rowId xmlns:a16="http://schemas.microsoft.com/office/drawing/2014/main" val="10003"/>
-                  </a:ext>
-                </a:extLst>
               </a:tr>
               <a:tr h="640080">
                 <a:tc>
@@ -13734,11 +12939,6 @@
                     </a:solidFill>
                   </a:tcPr>
                 </a:tc>
-                <a:extLst>
-                  <a:ext uri="{0D108BD9-81ED-4DB2-BD59-A6C34878D82A}">
-                    <a16:rowId xmlns:a16="http://schemas.microsoft.com/office/drawing/2014/main" val="10004"/>
-                  </a:ext>
-                </a:extLst>
               </a:tr>
             </a:tbl>
           </a:graphicData>
@@ -13782,7 +12982,7 @@
           </a:fontRef>
         </p:style>
         <p:txBody>
-          <a:bodyPr wrap="square" lIns="228600" tIns="228600" rIns="228600" bIns="228600" rtlCol="0" anchor="ctr"/>
+          <a:bodyPr rtlCol="0" anchor="ctr" wrap="square" lIns="228600" rIns="228600" tIns="228600" bIns="228600"/>
           <a:lstStyle/>
           <a:p>
             <a:pPr algn="ctr">
@@ -13892,7 +13092,6 @@
           <a:lstStyle/>
           <a:p>
             <a:pPr algn="ctr"/>
-            <a:endParaRPr/>
           </a:p>
         </p:txBody>
       </p:sp>
@@ -13919,7 +13118,7 @@
           <a:lstStyle/>
           <a:p>
             <a:pPr algn="ctr">
-              <a:defRPr sz="1500" b="1">
+              <a:defRPr b="1" sz="1500">
                 <a:solidFill>
                   <a:srgbClr val="0E8C61"/>
                 </a:solidFill>
@@ -13970,7 +13169,7 @@
           </a:fontRef>
         </p:style>
         <p:txBody>
-          <a:bodyPr wrap="square" rtlCol="0" anchor="ctr"/>
+          <a:bodyPr rtlCol="0" anchor="ctr" wrap="square"/>
           <a:lstStyle/>
           <a:p>
             <a:pPr algn="ctr">
@@ -14029,7 +13228,6 @@
           <a:lstStyle/>
           <a:p>
             <a:pPr algn="ctr"/>
-            <a:endParaRPr/>
           </a:p>
         </p:txBody>
       </p:sp>
@@ -14075,7 +13273,6 @@
           <a:lstStyle/>
           <a:p>
             <a:pPr algn="ctr"/>
-            <a:endParaRPr/>
           </a:p>
         </p:txBody>
       </p:sp>
@@ -14117,14 +13314,14 @@
           </a:fontRef>
         </p:style>
         <p:txBody>
-          <a:bodyPr wrap="square" rtlCol="0" anchor="ctr"/>
+          <a:bodyPr rtlCol="0" anchor="ctr" wrap="square"/>
           <a:lstStyle/>
           <a:p>
             <a:pPr algn="ctr">
               <a:spcAft>
                 <a:spcPts val="1000"/>
               </a:spcAft>
-              <a:defRPr sz="1200" b="1">
+              <a:defRPr b="1" sz="1200">
                 <a:solidFill>
                   <a:srgbClr val="0F172A"/>
                 </a:solidFill>
@@ -14155,7 +13352,7 @@
           </a:p>
           <a:p>
             <a:pPr>
-              <a:defRPr sz="1200" b="1">
+              <a:defRPr b="1" sz="1200">
                 <a:solidFill>
                   <a:srgbClr val="15803D"/>
                 </a:solidFill>
@@ -14205,14 +13402,14 @@
           </a:fontRef>
         </p:style>
         <p:txBody>
-          <a:bodyPr wrap="square" rtlCol="0" anchor="ctr"/>
+          <a:bodyPr rtlCol="0" anchor="ctr" wrap="square"/>
           <a:lstStyle/>
           <a:p>
             <a:pPr algn="ctr">
               <a:spcAft>
                 <a:spcPts val="1000"/>
               </a:spcAft>
-              <a:defRPr sz="1200" b="1">
+              <a:defRPr b="1" sz="1200">
                 <a:solidFill>
                   <a:srgbClr val="0F172A"/>
                 </a:solidFill>
@@ -14243,7 +13440,7 @@
           </a:p>
           <a:p>
             <a:pPr>
-              <a:defRPr sz="1200" b="1">
+              <a:defRPr b="1" sz="1200">
                 <a:solidFill>
                   <a:srgbClr val="B91C1C"/>
                 </a:solidFill>
@@ -14333,7 +13530,7 @@
           <a:noFill/>
         </p:spPr>
         <p:txBody>
-          <a:bodyPr wrap="square" lIns="0" tIns="0" rIns="0" bIns="0">
+          <a:bodyPr wrap="square" lIns="0" rIns="0" tIns="0" bIns="0">
             <a:spAutoFit/>
           </a:bodyPr>
           <a:lstStyle/>
@@ -14394,7 +13591,6 @@
           <a:lstStyle/>
           <a:p>
             <a:pPr algn="ctr"/>
-            <a:endParaRPr/>
           </a:p>
         </p:txBody>
       </p:sp>
@@ -14415,7 +13611,7 @@
           <a:noFill/>
         </p:spPr>
         <p:txBody>
-          <a:bodyPr wrap="square" lIns="0" tIns="0" rIns="0" bIns="0">
+          <a:bodyPr wrap="square" lIns="0" rIns="0" tIns="0" bIns="0">
             <a:spAutoFit/>
           </a:bodyPr>
           <a:lstStyle/>
@@ -14453,27 +13649,9 @@
                 <a:tableStyleId>{5C22544A-7EE6-4342-B048-85BDC9FD1C3A}</a:tableStyleId>
               </a:tblPr>
               <a:tblGrid>
-                <a:gridCol w="3413760">
-                  <a:extLst>
-                    <a:ext uri="{9D8B030D-6E8A-4147-A177-3AD203B41FA5}">
-                      <a16:colId xmlns:a16="http://schemas.microsoft.com/office/drawing/2014/main" val="20000"/>
-                    </a:ext>
-                  </a:extLst>
-                </a:gridCol>
-                <a:gridCol w="3413760">
-                  <a:extLst>
-                    <a:ext uri="{9D8B030D-6E8A-4147-A177-3AD203B41FA5}">
-                      <a16:colId xmlns:a16="http://schemas.microsoft.com/office/drawing/2014/main" val="20001"/>
-                    </a:ext>
-                  </a:extLst>
-                </a:gridCol>
-                <a:gridCol w="3413760">
-                  <a:extLst>
-                    <a:ext uri="{9D8B030D-6E8A-4147-A177-3AD203B41FA5}">
-                      <a16:colId xmlns:a16="http://schemas.microsoft.com/office/drawing/2014/main" val="20002"/>
-                    </a:ext>
-                  </a:extLst>
-                </a:gridCol>
+                <a:gridCol w="3413760"/>
+                <a:gridCol w="3413760"/>
+                <a:gridCol w="3413760"/>
               </a:tblGrid>
               <a:tr h="731520">
                 <a:tc>
@@ -14548,11 +13726,6 @@
                     </a:solidFill>
                   </a:tcPr>
                 </a:tc>
-                <a:extLst>
-                  <a:ext uri="{0D108BD9-81ED-4DB2-BD59-A6C34878D82A}">
-                    <a16:rowId xmlns:a16="http://schemas.microsoft.com/office/drawing/2014/main" val="10000"/>
-                  </a:ext>
-                </a:extLst>
               </a:tr>
               <a:tr h="731520">
                 <a:tc>
@@ -14627,11 +13800,6 @@
                     </a:solidFill>
                   </a:tcPr>
                 </a:tc>
-                <a:extLst>
-                  <a:ext uri="{0D108BD9-81ED-4DB2-BD59-A6C34878D82A}">
-                    <a16:rowId xmlns:a16="http://schemas.microsoft.com/office/drawing/2014/main" val="10001"/>
-                  </a:ext>
-                </a:extLst>
               </a:tr>
               <a:tr h="731520">
                 <a:tc>
@@ -14706,11 +13874,6 @@
                     </a:solidFill>
                   </a:tcPr>
                 </a:tc>
-                <a:extLst>
-                  <a:ext uri="{0D108BD9-81ED-4DB2-BD59-A6C34878D82A}">
-                    <a16:rowId xmlns:a16="http://schemas.microsoft.com/office/drawing/2014/main" val="10002"/>
-                  </a:ext>
-                </a:extLst>
               </a:tr>
               <a:tr h="731520">
                 <a:tc>
@@ -14785,11 +13948,6 @@
                     </a:solidFill>
                   </a:tcPr>
                 </a:tc>
-                <a:extLst>
-                  <a:ext uri="{0D108BD9-81ED-4DB2-BD59-A6C34878D82A}">
-                    <a16:rowId xmlns:a16="http://schemas.microsoft.com/office/drawing/2014/main" val="10003"/>
-                  </a:ext>
-                </a:extLst>
               </a:tr>
             </a:tbl>
           </a:graphicData>
@@ -14833,7 +13991,7 @@
           </a:fontRef>
         </p:style>
         <p:txBody>
-          <a:bodyPr wrap="square" lIns="228600" tIns="228600" rIns="228600" bIns="228600" rtlCol="0" anchor="ctr"/>
+          <a:bodyPr rtlCol="0" anchor="ctr" wrap="square" lIns="228600" rIns="228600" tIns="228600" bIns="228600"/>
           <a:lstStyle/>
           <a:p>
             <a:pPr algn="ctr">
@@ -14939,7 +14097,7 @@
           </a:fontRef>
         </p:style>
         <p:txBody>
-          <a:bodyPr wrap="square" lIns="182880" tIns="182880" rIns="182880" bIns="182880" rtlCol="0" anchor="ctr"/>
+          <a:bodyPr rtlCol="0" anchor="ctr" wrap="square" lIns="182880" rIns="182880" tIns="182880" bIns="182880"/>
           <a:lstStyle/>
           <a:p>
             <a:pPr algn="ctr">

</xml_diff>